<commit_message>
Finished presentation and fixed other things
</commit_message>
<xml_diff>
--- a/presentation/Brazil_Marketplace_in_Motion.pptx
+++ b/presentation/Brazil_Marketplace_in_Motion.pptx
@@ -4,6 +4,9 @@
   <p:sldMasterIdLst>
     <p:sldMasterId id="2147483648" r:id="rId1"/>
   </p:sldMasterIdLst>
+  <p:notesMasterIdLst>
+    <p:notesMasterId r:id="rId12"/>
+  </p:notesMasterIdLst>
   <p:sldIdLst>
     <p:sldId id="256" r:id="rId2"/>
     <p:sldId id="257" r:id="rId3"/>
@@ -16,9 +19,6 @@
     <p:sldId id="264" r:id="rId10"/>
     <p:sldId id="265" r:id="rId11"/>
   </p:sldIdLst>
-  <p:notesMasterIdLst>
-    <p:notesMasterId r:id="rId12"/>
-  </p:notesMasterIdLst>
   <p:sldSz cx="12192000" cy="6858000"/>
   <p:notesSz cx="6858000" cy="12192000"/>
   <p:defaultTextStyle>
@@ -113,7 +113,234 @@
       </a:defRPr>
     </a:lvl9pPr>
   </p:defaultTextStyle>
+  <p:extLst>
+    <p:ext uri="{EFAFB233-063F-42B5-8137-9DF3F51BA10A}">
+      <p15:sldGuideLst xmlns:p15="http://schemas.microsoft.com/office/powerpoint/2012/main"/>
+    </p:ext>
+  </p:extLst>
 </p:presentation>
+</file>
+
+<file path=ppt/revisionInfo.xml><?xml version="1.0" encoding="utf-8"?>
+<p1510:revInfo xmlns:a="http://schemas.openxmlformats.org/drawingml/2006/main" xmlns:r="http://schemas.openxmlformats.org/officeDocument/2006/relationships" xmlns:p1510="http://schemas.microsoft.com/office/powerpoint/2015/10/main">
+  <p1510:revLst>
+    <p1510:client id="{DD5BB8BA-0F8D-471A-B594-A9ED77B1BB18}" v="30" dt="2026-07-17T12:53:47.887"/>
+  </p1510:revLst>
+</p1510:revInfo>
+</file>
+
+<file path=ppt/changesInfos/changesInfo1.xml><?xml version="1.0" encoding="utf-8"?>
+<pc:chgInfo xmlns:a="http://schemas.openxmlformats.org/drawingml/2006/main" xmlns:r="http://schemas.openxmlformats.org/officeDocument/2006/relationships" xmlns:ac="http://schemas.microsoft.com/office/drawing/2013/main/command" xmlns:pc="http://schemas.microsoft.com/office/powerpoint/2013/main/command">
+  <pc:docChgLst>
+    <pc:chgData name="Guilherme Avella" userId="8f714fdc1d77ebfe" providerId="LiveId" clId="{8C68FAF7-BC27-4596-9C06-050D2A58E361}"/>
+    <pc:docChg chg="undo custSel modSld">
+      <pc:chgData name="Guilherme Avella" userId="8f714fdc1d77ebfe" providerId="LiveId" clId="{8C68FAF7-BC27-4596-9C06-050D2A58E361}" dt="2026-07-17T12:56:22.582" v="102" actId="20577"/>
+      <pc:docMkLst>
+        <pc:docMk/>
+      </pc:docMkLst>
+      <pc:sldChg chg="addSp delSp modSp mod">
+        <pc:chgData name="Guilherme Avella" userId="8f714fdc1d77ebfe" providerId="LiveId" clId="{8C68FAF7-BC27-4596-9C06-050D2A58E361}" dt="2026-07-17T12:46:06.973" v="29" actId="1076"/>
+        <pc:sldMkLst>
+          <pc:docMk/>
+          <pc:sldMk cId="0" sldId="258"/>
+        </pc:sldMkLst>
+        <pc:picChg chg="del mod modCrop">
+          <ac:chgData name="Guilherme Avella" userId="8f714fdc1d77ebfe" providerId="LiveId" clId="{8C68FAF7-BC27-4596-9C06-050D2A58E361}" dt="2026-07-17T12:45:55.494" v="24" actId="478"/>
+          <ac:picMkLst>
+            <pc:docMk/>
+            <pc:sldMk cId="0" sldId="258"/>
+            <ac:picMk id="5" creationId="{00000000-0000-0000-0000-000000000000}"/>
+          </ac:picMkLst>
+        </pc:picChg>
+        <pc:picChg chg="add mod">
+          <ac:chgData name="Guilherme Avella" userId="8f714fdc1d77ebfe" providerId="LiveId" clId="{8C68FAF7-BC27-4596-9C06-050D2A58E361}" dt="2026-07-17T12:46:06.973" v="29" actId="1076"/>
+          <ac:picMkLst>
+            <pc:docMk/>
+            <pc:sldMk cId="0" sldId="258"/>
+            <ac:picMk id="11" creationId="{A7943774-7EB2-CA05-94DA-92048183ACBF}"/>
+          </ac:picMkLst>
+        </pc:picChg>
+      </pc:sldChg>
+      <pc:sldChg chg="modSp mod">
+        <pc:chgData name="Guilherme Avella" userId="8f714fdc1d77ebfe" providerId="LiveId" clId="{8C68FAF7-BC27-4596-9C06-050D2A58E361}" dt="2026-07-17T12:46:15.717" v="30" actId="14826"/>
+        <pc:sldMkLst>
+          <pc:docMk/>
+          <pc:sldMk cId="0" sldId="259"/>
+        </pc:sldMkLst>
+        <pc:picChg chg="mod">
+          <ac:chgData name="Guilherme Avella" userId="8f714fdc1d77ebfe" providerId="LiveId" clId="{8C68FAF7-BC27-4596-9C06-050D2A58E361}" dt="2026-07-17T12:46:15.717" v="30" actId="14826"/>
+          <ac:picMkLst>
+            <pc:docMk/>
+            <pc:sldMk cId="0" sldId="259"/>
+            <ac:picMk id="5" creationId="{00000000-0000-0000-0000-000000000000}"/>
+          </ac:picMkLst>
+        </pc:picChg>
+      </pc:sldChg>
+      <pc:sldChg chg="modSp mod">
+        <pc:chgData name="Guilherme Avella" userId="8f714fdc1d77ebfe" providerId="LiveId" clId="{8C68FAF7-BC27-4596-9C06-050D2A58E361}" dt="2026-07-17T12:46:34.185" v="32" actId="1076"/>
+        <pc:sldMkLst>
+          <pc:docMk/>
+          <pc:sldMk cId="0" sldId="260"/>
+        </pc:sldMkLst>
+        <pc:picChg chg="mod">
+          <ac:chgData name="Guilherme Avella" userId="8f714fdc1d77ebfe" providerId="LiveId" clId="{8C68FAF7-BC27-4596-9C06-050D2A58E361}" dt="2026-07-17T12:46:34.185" v="32" actId="1076"/>
+          <ac:picMkLst>
+            <pc:docMk/>
+            <pc:sldMk cId="0" sldId="260"/>
+            <ac:picMk id="5" creationId="{00000000-0000-0000-0000-000000000000}"/>
+          </ac:picMkLst>
+        </pc:picChg>
+      </pc:sldChg>
+      <pc:sldChg chg="modSp">
+        <pc:chgData name="Guilherme Avella" userId="8f714fdc1d77ebfe" providerId="LiveId" clId="{8C68FAF7-BC27-4596-9C06-050D2A58E361}" dt="2026-07-17T12:46:51.905" v="34" actId="14826"/>
+        <pc:sldMkLst>
+          <pc:docMk/>
+          <pc:sldMk cId="0" sldId="261"/>
+        </pc:sldMkLst>
+        <pc:picChg chg="mod">
+          <ac:chgData name="Guilherme Avella" userId="8f714fdc1d77ebfe" providerId="LiveId" clId="{8C68FAF7-BC27-4596-9C06-050D2A58E361}" dt="2026-07-17T12:46:46.120" v="33" actId="14826"/>
+          <ac:picMkLst>
+            <pc:docMk/>
+            <pc:sldMk cId="0" sldId="261"/>
+            <ac:picMk id="5" creationId="{00000000-0000-0000-0000-000000000000}"/>
+          </ac:picMkLst>
+        </pc:picChg>
+        <pc:picChg chg="mod">
+          <ac:chgData name="Guilherme Avella" userId="8f714fdc1d77ebfe" providerId="LiveId" clId="{8C68FAF7-BC27-4596-9C06-050D2A58E361}" dt="2026-07-17T12:46:51.905" v="34" actId="14826"/>
+          <ac:picMkLst>
+            <pc:docMk/>
+            <pc:sldMk cId="0" sldId="261"/>
+            <ac:picMk id="6" creationId="{00000000-0000-0000-0000-000000000000}"/>
+          </ac:picMkLst>
+        </pc:picChg>
+      </pc:sldChg>
+      <pc:sldChg chg="modSp">
+        <pc:chgData name="Guilherme Avella" userId="8f714fdc1d77ebfe" providerId="LiveId" clId="{8C68FAF7-BC27-4596-9C06-050D2A58E361}" dt="2026-07-17T12:48:11.435" v="38" actId="14826"/>
+        <pc:sldMkLst>
+          <pc:docMk/>
+          <pc:sldMk cId="0" sldId="262"/>
+        </pc:sldMkLst>
+        <pc:picChg chg="mod">
+          <ac:chgData name="Guilherme Avella" userId="8f714fdc1d77ebfe" providerId="LiveId" clId="{8C68FAF7-BC27-4596-9C06-050D2A58E361}" dt="2026-07-17T12:47:09.616" v="35" actId="14826"/>
+          <ac:picMkLst>
+            <pc:docMk/>
+            <pc:sldMk cId="0" sldId="262"/>
+            <ac:picMk id="5" creationId="{00000000-0000-0000-0000-000000000000}"/>
+          </ac:picMkLst>
+        </pc:picChg>
+        <pc:picChg chg="mod">
+          <ac:chgData name="Guilherme Avella" userId="8f714fdc1d77ebfe" providerId="LiveId" clId="{8C68FAF7-BC27-4596-9C06-050D2A58E361}" dt="2026-07-17T12:48:11.435" v="38" actId="14826"/>
+          <ac:picMkLst>
+            <pc:docMk/>
+            <pc:sldMk cId="0" sldId="262"/>
+            <ac:picMk id="6" creationId="{00000000-0000-0000-0000-000000000000}"/>
+          </ac:picMkLst>
+        </pc:picChg>
+      </pc:sldChg>
+      <pc:sldChg chg="modSp">
+        <pc:chgData name="Guilherme Avella" userId="8f714fdc1d77ebfe" providerId="LiveId" clId="{8C68FAF7-BC27-4596-9C06-050D2A58E361}" dt="2026-07-17T12:49:33.813" v="40" actId="14826"/>
+        <pc:sldMkLst>
+          <pc:docMk/>
+          <pc:sldMk cId="0" sldId="263"/>
+        </pc:sldMkLst>
+        <pc:picChg chg="mod">
+          <ac:chgData name="Guilherme Avella" userId="8f714fdc1d77ebfe" providerId="LiveId" clId="{8C68FAF7-BC27-4596-9C06-050D2A58E361}" dt="2026-07-17T12:48:33.583" v="39" actId="14826"/>
+          <ac:picMkLst>
+            <pc:docMk/>
+            <pc:sldMk cId="0" sldId="263"/>
+            <ac:picMk id="5" creationId="{00000000-0000-0000-0000-000000000000}"/>
+          </ac:picMkLst>
+        </pc:picChg>
+        <pc:picChg chg="mod">
+          <ac:chgData name="Guilherme Avella" userId="8f714fdc1d77ebfe" providerId="LiveId" clId="{8C68FAF7-BC27-4596-9C06-050D2A58E361}" dt="2026-07-17T12:49:33.813" v="40" actId="14826"/>
+          <ac:picMkLst>
+            <pc:docMk/>
+            <pc:sldMk cId="0" sldId="263"/>
+            <ac:picMk id="6" creationId="{00000000-0000-0000-0000-000000000000}"/>
+          </ac:picMkLst>
+        </pc:picChg>
+      </pc:sldChg>
+      <pc:sldChg chg="modSp mod">
+        <pc:chgData name="Guilherme Avella" userId="8f714fdc1d77ebfe" providerId="LiveId" clId="{8C68FAF7-BC27-4596-9C06-050D2A58E361}" dt="2026-07-17T12:54:03.924" v="70" actId="14100"/>
+        <pc:sldMkLst>
+          <pc:docMk/>
+          <pc:sldMk cId="0" sldId="264"/>
+        </pc:sldMkLst>
+        <pc:spChg chg="mod">
+          <ac:chgData name="Guilherme Avella" userId="8f714fdc1d77ebfe" providerId="LiveId" clId="{8C68FAF7-BC27-4596-9C06-050D2A58E361}" dt="2026-07-17T12:51:32.665" v="45"/>
+          <ac:spMkLst>
+            <pc:docMk/>
+            <pc:sldMk cId="0" sldId="264"/>
+            <ac:spMk id="11" creationId="{00000000-0000-0000-0000-000000000000}"/>
+          </ac:spMkLst>
+        </pc:spChg>
+        <pc:spChg chg="mod">
+          <ac:chgData name="Guilherme Avella" userId="8f714fdc1d77ebfe" providerId="LiveId" clId="{8C68FAF7-BC27-4596-9C06-050D2A58E361}" dt="2026-07-17T12:53:45.901" v="65" actId="14100"/>
+          <ac:spMkLst>
+            <pc:docMk/>
+            <pc:sldMk cId="0" sldId="264"/>
+            <ac:spMk id="21" creationId="{00000000-0000-0000-0000-000000000000}"/>
+          </ac:spMkLst>
+        </pc:spChg>
+        <pc:spChg chg="mod">
+          <ac:chgData name="Guilherme Avella" userId="8f714fdc1d77ebfe" providerId="LiveId" clId="{8C68FAF7-BC27-4596-9C06-050D2A58E361}" dt="2026-07-17T12:54:03.924" v="70" actId="14100"/>
+          <ac:spMkLst>
+            <pc:docMk/>
+            <pc:sldMk cId="0" sldId="264"/>
+            <ac:spMk id="22" creationId="{00000000-0000-0000-0000-000000000000}"/>
+          </ac:spMkLst>
+        </pc:spChg>
+        <pc:picChg chg="mod">
+          <ac:chgData name="Guilherme Avella" userId="8f714fdc1d77ebfe" providerId="LiveId" clId="{8C68FAF7-BC27-4596-9C06-050D2A58E361}" dt="2026-07-17T12:49:45.547" v="41" actId="14826"/>
+          <ac:picMkLst>
+            <pc:docMk/>
+            <pc:sldMk cId="0" sldId="264"/>
+            <ac:picMk id="12" creationId="{00000000-0000-0000-0000-000000000000}"/>
+          </ac:picMkLst>
+        </pc:picChg>
+        <pc:picChg chg="mod">
+          <ac:chgData name="Guilherme Avella" userId="8f714fdc1d77ebfe" providerId="LiveId" clId="{8C68FAF7-BC27-4596-9C06-050D2A58E361}" dt="2026-07-17T12:49:52.636" v="42" actId="14826"/>
+          <ac:picMkLst>
+            <pc:docMk/>
+            <pc:sldMk cId="0" sldId="264"/>
+            <ac:picMk id="13" creationId="{00000000-0000-0000-0000-000000000000}"/>
+          </ac:picMkLst>
+        </pc:picChg>
+        <pc:picChg chg="mod">
+          <ac:chgData name="Guilherme Avella" userId="8f714fdc1d77ebfe" providerId="LiveId" clId="{8C68FAF7-BC27-4596-9C06-050D2A58E361}" dt="2026-07-17T12:50:10.031" v="44" actId="14826"/>
+          <ac:picMkLst>
+            <pc:docMk/>
+            <pc:sldMk cId="0" sldId="264"/>
+            <ac:picMk id="14" creationId="{00000000-0000-0000-0000-000000000000}"/>
+          </ac:picMkLst>
+        </pc:picChg>
+        <pc:picChg chg="mod">
+          <ac:chgData name="Guilherme Avella" userId="8f714fdc1d77ebfe" providerId="LiveId" clId="{8C68FAF7-BC27-4596-9C06-050D2A58E361}" dt="2026-07-17T12:50:00.914" v="43" actId="14826"/>
+          <ac:picMkLst>
+            <pc:docMk/>
+            <pc:sldMk cId="0" sldId="264"/>
+            <ac:picMk id="15" creationId="{00000000-0000-0000-0000-000000000000}"/>
+          </ac:picMkLst>
+        </pc:picChg>
+      </pc:sldChg>
+      <pc:sldChg chg="modSp mod">
+        <pc:chgData name="Guilherme Avella" userId="8f714fdc1d77ebfe" providerId="LiveId" clId="{8C68FAF7-BC27-4596-9C06-050D2A58E361}" dt="2026-07-17T12:56:22.582" v="102" actId="20577"/>
+        <pc:sldMkLst>
+          <pc:docMk/>
+          <pc:sldMk cId="0" sldId="265"/>
+        </pc:sldMkLst>
+        <pc:spChg chg="mod">
+          <ac:chgData name="Guilherme Avella" userId="8f714fdc1d77ebfe" providerId="LiveId" clId="{8C68FAF7-BC27-4596-9C06-050D2A58E361}" dt="2026-07-17T12:56:22.582" v="102" actId="20577"/>
+          <ac:spMkLst>
+            <pc:docMk/>
+            <pc:sldMk cId="0" sldId="265"/>
+            <ac:spMk id="4" creationId="{00000000-0000-0000-0000-000000000000}"/>
+          </ac:spMkLst>
+        </pc:spChg>
+      </pc:sldChg>
+    </pc:docChg>
+  </pc:docChgLst>
+</pc:chgInfo>
 </file>
 
 <file path=ppt/notesMasters/notesMaster1.xml><?xml version="1.0" encoding="utf-8"?>
@@ -138,234 +365,10 @@
           <a:chExt cx="0" cy="0"/>
         </a:xfrm>
       </p:grpSpPr>
-      <p:sp>
-        <p:nvSpPr>
-          <p:cNvPr id="2" name="Header Placeholder 1"/>
-          <p:cNvSpPr>
-            <a:spLocks noGrp="1"/>
-          </p:cNvSpPr>
-          <p:nvPr>
-            <p:ph type="hdr" sz="quarter"/>
-          </p:nvPr>
-        </p:nvSpPr>
-        <p:spPr>
-          <a:xfrm>
-            <a:off x="0" y="0"/>
-            <a:ext cx="2971800" cy="458788"/>
-          </a:xfrm>
-          <a:prstGeom prst="rect">
-            <a:avLst/>
-          </a:prstGeom>
-        </p:spPr>
-        <p:txBody>
-          <a:bodyPr vert="horz" lIns="91440" tIns="45720" rIns="91440" bIns="45720" rtlCol="0"/>
-          <a:lstStyle>
-            <a:lvl1pPr algn="l">
-              <a:defRPr sz="1200"/>
-            </a:lvl1pPr>
-          </a:lstStyle>
-          <a:p>
-            <a:endParaRPr lang="en-US"/>
-          </a:p>
-        </p:txBody>
-      </p:sp>
-      <p:sp>
-        <p:nvSpPr>
-          <p:cNvPr id="3" name="Date Placeholder 2"/>
-          <p:cNvSpPr>
-            <a:spLocks noGrp="1"/>
-          </p:cNvSpPr>
-          <p:nvPr>
-            <p:ph type="dt" idx="1"/>
-          </p:nvPr>
-        </p:nvSpPr>
-        <p:spPr>
-          <a:xfrm>
-            <a:off x="3884613" y="0"/>
-            <a:ext cx="2971800" cy="458788"/>
-          </a:xfrm>
-          <a:prstGeom prst="rect">
-            <a:avLst/>
-          </a:prstGeom>
-        </p:spPr>
-        <p:txBody>
-          <a:bodyPr vert="horz" lIns="91440" tIns="45720" rIns="91440" bIns="45720" rtlCol="0"/>
-          <a:lstStyle>
-            <a:lvl1pPr algn="r">
-              <a:defRPr sz="1200"/>
-            </a:lvl1pPr>
-          </a:lstStyle>
-          <a:p>
-            <a:fld id="{5282F153-3F37-0F45-9E97-73ACFA13230C}" type="datetimeFigureOut">
-              <a:rPr lang="en-US"/>
-              <a:t>7/23/19</a:t>
-            </a:fld>
-            <a:endParaRPr lang="en-US"/>
-          </a:p>
-        </p:txBody>
-      </p:sp>
-      <p:sp>
-        <p:nvSpPr>
-          <p:cNvPr id="4" name="Slide Image Placeholder 3"/>
-          <p:cNvSpPr>
-            <a:spLocks noGrp="1" noRot="1" noChangeAspect="1"/>
-          </p:cNvSpPr>
-          <p:nvPr>
-            <p:ph type="sldImg" idx="2"/>
-          </p:nvPr>
-        </p:nvSpPr>
-        <p:spPr>
-          <a:xfrm>
-            <a:off x="685800" y="1143000"/>
-            <a:ext cx="5486400" cy="3086100"/>
-          </a:xfrm>
-          <a:prstGeom prst="rect">
-            <a:avLst/>
-          </a:prstGeom>
-          <a:noFill/>
-          <a:ln w="12700">
-            <a:solidFill>
-              <a:prstClr val="black"/>
-            </a:solidFill>
-          </a:ln>
-        </p:spPr>
-        <p:txBody>
-          <a:bodyPr vert="horz" lIns="91440" tIns="45720" rIns="91440" bIns="45720" rtlCol="0" anchor="ctr"/>
-          <a:lstStyle/>
-          <a:p>
-            <a:endParaRPr lang="en-US"/>
-          </a:p>
-        </p:txBody>
-      </p:sp>
-      <p:sp>
-        <p:nvSpPr>
-          <p:cNvPr id="5" name="Notes Placeholder 4"/>
-          <p:cNvSpPr>
-            <a:spLocks noGrp="1"/>
-          </p:cNvSpPr>
-          <p:nvPr>
-            <p:ph type="body" sz="quarter" idx="3"/>
-          </p:nvPr>
-        </p:nvSpPr>
-        <p:spPr>
-          <a:xfrm>
-            <a:off x="685800" y="4400550"/>
-            <a:ext cx="5486400" cy="3600450"/>
-          </a:xfrm>
-          <a:prstGeom prst="rect">
-            <a:avLst/>
-          </a:prstGeom>
-        </p:spPr>
-        <p:txBody>
-          <a:bodyPr vert="horz" lIns="91440" tIns="45720" rIns="91440" bIns="45720" rtlCol="0"/>
-          <a:lstStyle/>
-          <a:p>
-            <a:pPr lvl="0"/>
-            <a:r>
-              <a:rPr lang="en-US"/>
-              <a:t>Click to edit Master text styles</a:t>
-            </a:r>
-          </a:p>
-          <a:p>
-            <a:pPr lvl="1"/>
-            <a:r>
-              <a:rPr lang="en-US"/>
-              <a:t>Second level</a:t>
-            </a:r>
-          </a:p>
-          <a:p>
-            <a:pPr lvl="2"/>
-            <a:r>
-              <a:rPr lang="en-US"/>
-              <a:t>Third level</a:t>
-            </a:r>
-          </a:p>
-          <a:p>
-            <a:pPr lvl="3"/>
-            <a:r>
-              <a:rPr lang="en-US"/>
-              <a:t>Fourth level</a:t>
-            </a:r>
-          </a:p>
-          <a:p>
-            <a:pPr lvl="4"/>
-            <a:r>
-              <a:rPr lang="en-US"/>
-              <a:t>Fifth level</a:t>
-            </a:r>
-          </a:p>
-        </p:txBody>
-      </p:sp>
-      <p:sp>
-        <p:nvSpPr>
-          <p:cNvPr id="6" name="Footer Placeholder 5"/>
-          <p:cNvSpPr>
-            <a:spLocks noGrp="1"/>
-          </p:cNvSpPr>
-          <p:nvPr>
-            <p:ph type="ftr" sz="quarter" idx="4"/>
-          </p:nvPr>
-        </p:nvSpPr>
-        <p:spPr>
-          <a:xfrm>
-            <a:off x="0" y="8685213"/>
-            <a:ext cx="2971800" cy="458787"/>
-          </a:xfrm>
-          <a:prstGeom prst="rect">
-            <a:avLst/>
-          </a:prstGeom>
-        </p:spPr>
-        <p:txBody>
-          <a:bodyPr vert="horz" lIns="91440" tIns="45720" rIns="91440" bIns="45720" rtlCol="0" anchor="b"/>
-          <a:lstStyle>
-            <a:lvl1pPr algn="l">
-              <a:defRPr sz="1200"/>
-            </a:lvl1pPr>
-          </a:lstStyle>
-          <a:p>
-            <a:endParaRPr lang="en-US"/>
-          </a:p>
-        </p:txBody>
-      </p:sp>
-      <p:sp>
-        <p:nvSpPr>
-          <p:cNvPr id="7" name="Slide Number Placeholder 6"/>
-          <p:cNvSpPr>
-            <a:spLocks noGrp="1"/>
-          </p:cNvSpPr>
-          <p:nvPr>
-            <p:ph type="sldNum" sz="quarter" idx="5"/>
-          </p:nvPr>
-        </p:nvSpPr>
-        <p:spPr>
-          <a:xfrm>
-            <a:off x="3884613" y="8685213"/>
-            <a:ext cx="2971800" cy="458787"/>
-          </a:xfrm>
-          <a:prstGeom prst="rect">
-            <a:avLst/>
-          </a:prstGeom>
-        </p:spPr>
-        <p:txBody>
-          <a:bodyPr vert="horz" lIns="91440" tIns="45720" rIns="91440" bIns="45720" rtlCol="0" anchor="b"/>
-          <a:lstStyle>
-            <a:lvl1pPr algn="r">
-              <a:defRPr sz="1200"/>
-            </a:lvl1pPr>
-          </a:lstStyle>
-          <a:p>
-            <a:fld id="{CE5E9CC1-C706-0F49-92D6-E571CC5EEA8F}" type="slidenum">
-              <a:rPr lang="en-US"/>
-              <a:t>‹#›</a:t>
-            </a:fld>
-            <a:endParaRPr lang="en-US"/>
-          </a:p>
-        </p:txBody>
-      </p:sp>
     </p:spTree>
     <p:extLst>
       <p:ext uri="{BB962C8B-B14F-4D97-AF65-F5344CB8AC3E}">
-        <p14:creationId xmlns:p14="http://schemas.microsoft.com/office/powerpoint/2010/main" val="1024086991"/>
+        <p14:creationId xmlns:p14="http://schemas.microsoft.com/office/powerpoint/2010/main" val="338663985"/>
       </p:ext>
     </p:extLst>
   </p:cSld>
@@ -509,10 +512,6 @@
           <a:bodyPr/>
           <a:lstStyle/>
           <a:p>
-            <a:r>
-              <a:rPr lang="en-US" dirty="0"/>
-              <a:t/>
-            </a:r>
             <a:endParaRPr lang="en-US" dirty="0"/>
           </a:p>
         </p:txBody>
@@ -597,10 +596,6 @@
           <a:bodyPr/>
           <a:lstStyle/>
           <a:p>
-            <a:r>
-              <a:rPr lang="en-US" dirty="0"/>
-              <a:t/>
-            </a:r>
             <a:endParaRPr lang="en-US" dirty="0"/>
           </a:p>
         </p:txBody>
@@ -685,10 +680,6 @@
           <a:bodyPr/>
           <a:lstStyle/>
           <a:p>
-            <a:r>
-              <a:rPr lang="en-US" dirty="0"/>
-              <a:t/>
-            </a:r>
             <a:endParaRPr lang="en-US" dirty="0"/>
           </a:p>
         </p:txBody>
@@ -773,10 +764,6 @@
           <a:bodyPr/>
           <a:lstStyle/>
           <a:p>
-            <a:r>
-              <a:rPr lang="en-US" dirty="0"/>
-              <a:t/>
-            </a:r>
             <a:endParaRPr lang="en-US" dirty="0"/>
           </a:p>
         </p:txBody>
@@ -861,10 +848,6 @@
           <a:bodyPr/>
           <a:lstStyle/>
           <a:p>
-            <a:r>
-              <a:rPr lang="en-US" dirty="0"/>
-              <a:t/>
-            </a:r>
             <a:endParaRPr lang="en-US" dirty="0"/>
           </a:p>
         </p:txBody>
@@ -949,10 +932,6 @@
           <a:bodyPr/>
           <a:lstStyle/>
           <a:p>
-            <a:r>
-              <a:rPr lang="en-US" dirty="0"/>
-              <a:t/>
-            </a:r>
             <a:endParaRPr lang="en-US" dirty="0"/>
           </a:p>
         </p:txBody>
@@ -1037,10 +1016,6 @@
           <a:bodyPr/>
           <a:lstStyle/>
           <a:p>
-            <a:r>
-              <a:rPr lang="en-US" dirty="0"/>
-              <a:t/>
-            </a:r>
             <a:endParaRPr lang="en-US" dirty="0"/>
           </a:p>
         </p:txBody>
@@ -1125,10 +1100,6 @@
           <a:bodyPr/>
           <a:lstStyle/>
           <a:p>
-            <a:r>
-              <a:rPr lang="en-US" dirty="0"/>
-              <a:t/>
-            </a:r>
             <a:endParaRPr lang="en-US" dirty="0"/>
           </a:p>
         </p:txBody>
@@ -1213,10 +1184,6 @@
           <a:bodyPr/>
           <a:lstStyle/>
           <a:p>
-            <a:r>
-              <a:rPr lang="en-US" dirty="0"/>
-              <a:t/>
-            </a:r>
             <a:endParaRPr lang="en-US" dirty="0"/>
           </a:p>
         </p:txBody>
@@ -1301,10 +1268,6 @@
           <a:bodyPr/>
           <a:lstStyle/>
           <a:p>
-            <a:r>
-              <a:rPr lang="en-US" dirty="0"/>
-              <a:t/>
-            </a:r>
             <a:endParaRPr lang="en-US" dirty="0"/>
           </a:p>
         </p:txBody>
@@ -1378,6 +1341,11 @@
 <file path=ppt/slideMasters/slideMaster1.xml><?xml version="1.0" encoding="utf-8"?>
 <p:sldMaster xmlns:a="http://schemas.openxmlformats.org/drawingml/2006/main" xmlns:r="http://schemas.openxmlformats.org/officeDocument/2006/relationships" xmlns:p="http://schemas.openxmlformats.org/presentationml/2006/main">
   <p:cSld>
+    <p:bg>
+      <p:bgRef idx="1001">
+        <a:schemeClr val="bg1"/>
+      </p:bgRef>
+    </p:bg>
     <p:spTree>
       <p:nvGrpSpPr>
         <p:cNvPr id="1" name=""/>
@@ -1660,6 +1628,7 @@
         <a:solidFill>
           <a:srgbClr val="1B2A4A"/>
         </a:solidFill>
+        <a:effectLst/>
       </p:bgPr>
     </p:bg>
     <p:spTree>
@@ -1695,6 +1664,13 @@
           </a:solidFill>
           <a:ln/>
         </p:spPr>
+        <p:txBody>
+          <a:bodyPr/>
+          <a:lstStyle/>
+          <a:p>
+            <a:endParaRPr lang="de-DE"/>
+          </a:p>
+        </p:txBody>
       </p:sp>
       <p:sp>
         <p:nvSpPr>
@@ -1717,11 +1693,11 @@
           <a:bodyPr wrap="square" rtlCol="0" anchor="ctr"/>
           <a:lstStyle/>
           <a:p>
-            <a:pPr indent="0" marL="0">
-              <a:buNone/>
-            </a:pPr>
-            <a:r>
-              <a:rPr lang="en-US" sz="1300" b="1" spc="200" kern="0" dirty="0">
+            <a:pPr marL="0" indent="0">
+              <a:buNone/>
+            </a:pPr>
+            <a:r>
+              <a:rPr lang="en-US" sz="1300" b="1" kern="0" spc="200" dirty="0">
                 <a:solidFill>
                   <a:srgbClr val="F0C36D"/>
                 </a:solidFill>
@@ -1756,7 +1732,7 @@
           <a:bodyPr wrap="square" rtlCol="0" anchor="ctr"/>
           <a:lstStyle/>
           <a:p>
-            <a:pPr indent="0" marL="0">
+            <a:pPr marL="0" indent="0">
               <a:buNone/>
             </a:pPr>
             <a:r>
@@ -1795,7 +1771,7 @@
           <a:bodyPr wrap="square" rtlCol="0" anchor="ctr"/>
           <a:lstStyle/>
           <a:p>
-            <a:pPr indent="0" marL="0">
+            <a:pPr marL="0" indent="0">
               <a:buNone/>
             </a:pPr>
             <a:r>
@@ -1834,7 +1810,7 @@
           <a:bodyPr wrap="square" rtlCol="0" anchor="ctr"/>
           <a:lstStyle/>
           <a:p>
-            <a:pPr indent="0" marL="0">
+            <a:pPr marL="0" indent="0">
               <a:buNone/>
             </a:pPr>
             <a:r>
@@ -1873,7 +1849,7 @@
           <a:bodyPr wrap="square" rtlCol="0" anchor="ctr"/>
           <a:lstStyle/>
           <a:p>
-            <a:pPr indent="0" marL="0">
+            <a:pPr marL="0" indent="0">
               <a:buNone/>
             </a:pPr>
             <a:r>
@@ -1912,7 +1888,7 @@
           <a:bodyPr wrap="square" rtlCol="0" anchor="ctr"/>
           <a:lstStyle/>
           <a:p>
-            <a:pPr indent="0" marL="0">
+            <a:pPr marL="0" indent="0">
               <a:buNone/>
             </a:pPr>
             <a:r>
@@ -1951,7 +1927,7 @@
           <a:bodyPr wrap="square" rtlCol="0" anchor="ctr"/>
           <a:lstStyle/>
           <a:p>
-            <a:pPr indent="0" marL="0">
+            <a:pPr marL="0" indent="0">
               <a:buNone/>
             </a:pPr>
             <a:r>
@@ -1990,7 +1966,7 @@
           <a:bodyPr wrap="square" rtlCol="0" anchor="ctr"/>
           <a:lstStyle/>
           <a:p>
-            <a:pPr indent="0" marL="0">
+            <a:pPr marL="0" indent="0">
               <a:buNone/>
             </a:pPr>
             <a:r>
@@ -2029,7 +2005,7 @@
           <a:bodyPr wrap="square" rtlCol="0" anchor="ctr"/>
           <a:lstStyle/>
           <a:p>
-            <a:pPr indent="0" marL="0">
+            <a:pPr marL="0" indent="0">
               <a:buNone/>
             </a:pPr>
             <a:r>
@@ -2068,7 +2044,7 @@
           <a:bodyPr wrap="square" rtlCol="0" anchor="ctr"/>
           <a:lstStyle/>
           <a:p>
-            <a:pPr indent="0" marL="0">
+            <a:pPr marL="0" indent="0">
               <a:buNone/>
             </a:pPr>
             <a:r>
@@ -2107,7 +2083,7 @@
           <a:bodyPr wrap="square" rtlCol="0" anchor="ctr"/>
           <a:lstStyle/>
           <a:p>
-            <a:pPr indent="0" marL="0">
+            <a:pPr marL="0" indent="0">
               <a:buNone/>
             </a:pPr>
             <a:r>
@@ -2146,7 +2122,7 @@
           <a:bodyPr wrap="square" rtlCol="0" anchor="ctr"/>
           <a:lstStyle/>
           <a:p>
-            <a:pPr indent="0" marL="0">
+            <a:pPr marL="0" indent="0">
               <a:buNone/>
             </a:pPr>
             <a:r>
@@ -2180,6 +2156,7 @@
         <a:solidFill>
           <a:srgbClr val="1B2A4A"/>
         </a:solidFill>
+        <a:effectLst/>
       </p:bgPr>
     </p:bg>
     <p:spTree>
@@ -2215,6 +2192,13 @@
           </a:solidFill>
           <a:ln/>
         </p:spPr>
+        <p:txBody>
+          <a:bodyPr/>
+          <a:lstStyle/>
+          <a:p>
+            <a:endParaRPr lang="de-DE"/>
+          </a:p>
+        </p:txBody>
       </p:sp>
       <p:sp>
         <p:nvSpPr>
@@ -2237,11 +2221,11 @@
           <a:bodyPr wrap="square" rtlCol="0" anchor="ctr"/>
           <a:lstStyle/>
           <a:p>
-            <a:pPr indent="0" marL="0">
-              <a:buNone/>
-            </a:pPr>
-            <a:r>
-              <a:rPr lang="en-US" sz="1300" b="1" spc="200" kern="0" dirty="0">
+            <a:pPr marL="0" indent="0">
+              <a:buNone/>
+            </a:pPr>
+            <a:r>
+              <a:rPr lang="en-US" sz="1300" b="1" kern="0" spc="200" dirty="0">
                 <a:solidFill>
                   <a:srgbClr val="F0C36D"/>
                 </a:solidFill>
@@ -2276,7 +2260,7 @@
           <a:bodyPr wrap="square" rtlCol="0" anchor="ctr"/>
           <a:lstStyle/>
           <a:p>
-            <a:pPr indent="0" marL="0">
+            <a:pPr marL="0" indent="0">
               <a:buNone/>
             </a:pPr>
             <a:r>
@@ -2288,7 +2272,7 @@
                 <a:ea typeface="Cambria" pitchFamily="34" charset="-122"/>
                 <a:cs typeface="Cambria" pitchFamily="34" charset="-120"/>
               </a:rPr>
-              <a:t>What Olist should do next</a:t>
+              <a:t>What can be changed to improve:</a:t>
             </a:r>
             <a:endParaRPr lang="en-US" sz="3200" dirty="0"/>
           </a:p>
@@ -2313,6 +2297,13 @@
           </a:solidFill>
           <a:ln/>
         </p:spPr>
+        <p:txBody>
+          <a:bodyPr/>
+          <a:lstStyle/>
+          <a:p>
+            <a:endParaRPr lang="de-DE"/>
+          </a:p>
+        </p:txBody>
       </p:sp>
       <p:sp>
         <p:nvSpPr>
@@ -2335,7 +2326,7 @@
           <a:bodyPr wrap="square" rtlCol="0" anchor="ctr"/>
           <a:lstStyle/>
           <a:p>
-            <a:pPr algn="ctr" indent="0" marL="0">
+            <a:pPr marL="0" indent="0" algn="ctr">
               <a:buNone/>
             </a:pPr>
             <a:r>
@@ -2374,7 +2365,7 @@
           <a:bodyPr wrap="square" rtlCol="0" anchor="ctr"/>
           <a:lstStyle/>
           <a:p>
-            <a:pPr indent="0" marL="0">
+            <a:pPr marL="0" indent="0">
               <a:buNone/>
             </a:pPr>
             <a:r>
@@ -2413,7 +2404,7 @@
           <a:bodyPr wrap="square" rtlCol="0" anchor="ctr"/>
           <a:lstStyle/>
           <a:p>
-            <a:pPr indent="0" marL="0">
+            <a:pPr marL="0" indent="0">
               <a:buNone/>
             </a:pPr>
             <a:r>
@@ -2450,6 +2441,13 @@
           </a:solidFill>
           <a:ln/>
         </p:spPr>
+        <p:txBody>
+          <a:bodyPr/>
+          <a:lstStyle/>
+          <a:p>
+            <a:endParaRPr lang="de-DE"/>
+          </a:p>
+        </p:txBody>
       </p:sp>
       <p:sp>
         <p:nvSpPr>
@@ -2472,7 +2470,7 @@
           <a:bodyPr wrap="square" rtlCol="0" anchor="ctr"/>
           <a:lstStyle/>
           <a:p>
-            <a:pPr algn="ctr" indent="0" marL="0">
+            <a:pPr marL="0" indent="0" algn="ctr">
               <a:buNone/>
             </a:pPr>
             <a:r>
@@ -2511,7 +2509,7 @@
           <a:bodyPr wrap="square" rtlCol="0" anchor="ctr"/>
           <a:lstStyle/>
           <a:p>
-            <a:pPr indent="0" marL="0">
+            <a:pPr marL="0" indent="0">
               <a:buNone/>
             </a:pPr>
             <a:r>
@@ -2550,7 +2548,7 @@
           <a:bodyPr wrap="square" rtlCol="0" anchor="ctr"/>
           <a:lstStyle/>
           <a:p>
-            <a:pPr indent="0" marL="0">
+            <a:pPr marL="0" indent="0">
               <a:buNone/>
             </a:pPr>
             <a:r>
@@ -2587,6 +2585,13 @@
           </a:solidFill>
           <a:ln/>
         </p:spPr>
+        <p:txBody>
+          <a:bodyPr/>
+          <a:lstStyle/>
+          <a:p>
+            <a:endParaRPr lang="de-DE"/>
+          </a:p>
+        </p:txBody>
       </p:sp>
       <p:sp>
         <p:nvSpPr>
@@ -2609,7 +2614,7 @@
           <a:bodyPr wrap="square" rtlCol="0" anchor="ctr"/>
           <a:lstStyle/>
           <a:p>
-            <a:pPr algn="ctr" indent="0" marL="0">
+            <a:pPr marL="0" indent="0" algn="ctr">
               <a:buNone/>
             </a:pPr>
             <a:r>
@@ -2648,7 +2653,7 @@
           <a:bodyPr wrap="square" rtlCol="0" anchor="ctr"/>
           <a:lstStyle/>
           <a:p>
-            <a:pPr indent="0" marL="0">
+            <a:pPr marL="0" indent="0">
               <a:buNone/>
             </a:pPr>
             <a:r>
@@ -2687,7 +2692,7 @@
           <a:bodyPr wrap="square" rtlCol="0" anchor="ctr"/>
           <a:lstStyle/>
           <a:p>
-            <a:pPr indent="0" marL="0">
+            <a:pPr marL="0" indent="0">
               <a:buNone/>
             </a:pPr>
             <a:r>
@@ -2724,6 +2729,13 @@
           </a:solidFill>
           <a:ln/>
         </p:spPr>
+        <p:txBody>
+          <a:bodyPr/>
+          <a:lstStyle/>
+          <a:p>
+            <a:endParaRPr lang="de-DE"/>
+          </a:p>
+        </p:txBody>
       </p:sp>
       <p:sp>
         <p:nvSpPr>
@@ -2746,7 +2758,7 @@
           <a:bodyPr wrap="square" rtlCol="0" anchor="ctr"/>
           <a:lstStyle/>
           <a:p>
-            <a:pPr algn="ctr" indent="0" marL="0">
+            <a:pPr marL="0" indent="0" algn="ctr">
               <a:buNone/>
             </a:pPr>
             <a:r>
@@ -2785,7 +2797,7 @@
           <a:bodyPr wrap="square" rtlCol="0" anchor="ctr"/>
           <a:lstStyle/>
           <a:p>
-            <a:pPr indent="0" marL="0">
+            <a:pPr marL="0" indent="0">
               <a:buNone/>
             </a:pPr>
             <a:r>
@@ -2824,7 +2836,7 @@
           <a:bodyPr wrap="square" rtlCol="0" anchor="ctr"/>
           <a:lstStyle/>
           <a:p>
-            <a:pPr indent="0" marL="0">
+            <a:pPr marL="0" indent="0">
               <a:buNone/>
             </a:pPr>
             <a:r>
@@ -2863,7 +2875,7 @@
           <a:bodyPr wrap="square" rtlCol="0" anchor="ctr"/>
           <a:lstStyle/>
           <a:p>
-            <a:pPr indent="0" marL="0">
+            <a:pPr marL="0" indent="0">
               <a:buNone/>
             </a:pPr>
             <a:r>
@@ -2897,6 +2909,7 @@
         <a:solidFill>
           <a:srgbClr val="F5F1E8"/>
         </a:solidFill>
+        <a:effectLst/>
       </p:bgPr>
     </p:bg>
     <p:spTree>
@@ -2932,6 +2945,13 @@
           </a:solidFill>
           <a:ln/>
         </p:spPr>
+        <p:txBody>
+          <a:bodyPr/>
+          <a:lstStyle/>
+          <a:p>
+            <a:endParaRPr lang="de-DE"/>
+          </a:p>
+        </p:txBody>
       </p:sp>
       <p:sp>
         <p:nvSpPr>
@@ -2954,11 +2974,11 @@
           <a:bodyPr wrap="square" rtlCol="0" anchor="ctr"/>
           <a:lstStyle/>
           <a:p>
-            <a:pPr indent="0" marL="0">
-              <a:buNone/>
-            </a:pPr>
-            <a:r>
-              <a:rPr lang="en-US" sz="1300" b="1" spc="200" kern="0" dirty="0">
+            <a:pPr marL="0" indent="0">
+              <a:buNone/>
+            </a:pPr>
+            <a:r>
+              <a:rPr lang="en-US" sz="1300" b="1" kern="0" spc="200" dirty="0">
                 <a:solidFill>
                   <a:srgbClr val="0072B2"/>
                 </a:solidFill>
@@ -2993,7 +3013,7 @@
           <a:bodyPr wrap="square" rtlCol="0" anchor="ctr"/>
           <a:lstStyle/>
           <a:p>
-            <a:pPr indent="0" marL="0">
+            <a:pPr marL="0" indent="0">
               <a:buNone/>
             </a:pPr>
             <a:r>
@@ -3037,6 +3057,13 @@
             <a:prstDash val="solid"/>
           </a:ln>
         </p:spPr>
+        <p:txBody>
+          <a:bodyPr/>
+          <a:lstStyle/>
+          <a:p>
+            <a:endParaRPr lang="de-DE"/>
+          </a:p>
+        </p:txBody>
       </p:sp>
       <p:sp>
         <p:nvSpPr>
@@ -3057,6 +3084,13 @@
           </a:solidFill>
           <a:ln/>
         </p:spPr>
+        <p:txBody>
+          <a:bodyPr/>
+          <a:lstStyle/>
+          <a:p>
+            <a:endParaRPr lang="de-DE"/>
+          </a:p>
+        </p:txBody>
       </p:sp>
       <p:sp>
         <p:nvSpPr>
@@ -3079,7 +3113,7 @@
           <a:bodyPr wrap="square" rtlCol="0" anchor="ctr"/>
           <a:lstStyle/>
           <a:p>
-            <a:pPr indent="0" marL="0">
+            <a:pPr marL="0" indent="0">
               <a:buNone/>
             </a:pPr>
             <a:r>
@@ -3118,7 +3152,7 @@
           <a:bodyPr wrap="square" rtlCol="0" anchor="ctr"/>
           <a:lstStyle/>
           <a:p>
-            <a:pPr indent="0" marL="0">
+            <a:pPr marL="0" indent="0">
               <a:buNone/>
             </a:pPr>
             <a:r>
@@ -3162,6 +3196,13 @@
             <a:prstDash val="solid"/>
           </a:ln>
         </p:spPr>
+        <p:txBody>
+          <a:bodyPr/>
+          <a:lstStyle/>
+          <a:p>
+            <a:endParaRPr lang="de-DE"/>
+          </a:p>
+        </p:txBody>
       </p:sp>
       <p:sp>
         <p:nvSpPr>
@@ -3182,6 +3223,13 @@
           </a:solidFill>
           <a:ln/>
         </p:spPr>
+        <p:txBody>
+          <a:bodyPr/>
+          <a:lstStyle/>
+          <a:p>
+            <a:endParaRPr lang="de-DE"/>
+          </a:p>
+        </p:txBody>
       </p:sp>
       <p:sp>
         <p:nvSpPr>
@@ -3204,7 +3252,7 @@
           <a:bodyPr wrap="square" rtlCol="0" anchor="ctr"/>
           <a:lstStyle/>
           <a:p>
-            <a:pPr indent="0" marL="0">
+            <a:pPr marL="0" indent="0">
               <a:buNone/>
             </a:pPr>
             <a:r>
@@ -3243,7 +3291,7 @@
           <a:bodyPr wrap="square" rtlCol="0" anchor="ctr"/>
           <a:lstStyle/>
           <a:p>
-            <a:pPr indent="0" marL="0">
+            <a:pPr marL="0" indent="0">
               <a:buNone/>
             </a:pPr>
             <a:r>
@@ -3287,6 +3335,13 @@
             <a:prstDash val="solid"/>
           </a:ln>
         </p:spPr>
+        <p:txBody>
+          <a:bodyPr/>
+          <a:lstStyle/>
+          <a:p>
+            <a:endParaRPr lang="de-DE"/>
+          </a:p>
+        </p:txBody>
       </p:sp>
       <p:sp>
         <p:nvSpPr>
@@ -3307,6 +3362,13 @@
           </a:solidFill>
           <a:ln/>
         </p:spPr>
+        <p:txBody>
+          <a:bodyPr/>
+          <a:lstStyle/>
+          <a:p>
+            <a:endParaRPr lang="de-DE"/>
+          </a:p>
+        </p:txBody>
       </p:sp>
       <p:sp>
         <p:nvSpPr>
@@ -3329,7 +3391,7 @@
           <a:bodyPr wrap="square" rtlCol="0" anchor="ctr"/>
           <a:lstStyle/>
           <a:p>
-            <a:pPr indent="0" marL="0">
+            <a:pPr marL="0" indent="0">
               <a:buNone/>
             </a:pPr>
             <a:r>
@@ -3368,7 +3430,7 @@
           <a:bodyPr wrap="square" rtlCol="0" anchor="ctr"/>
           <a:lstStyle/>
           <a:p>
-            <a:pPr indent="0" marL="0">
+            <a:pPr marL="0" indent="0">
               <a:buNone/>
             </a:pPr>
             <a:r>
@@ -3412,6 +3474,13 @@
             <a:prstDash val="solid"/>
           </a:ln>
         </p:spPr>
+        <p:txBody>
+          <a:bodyPr/>
+          <a:lstStyle/>
+          <a:p>
+            <a:endParaRPr lang="de-DE"/>
+          </a:p>
+        </p:txBody>
       </p:sp>
       <p:sp>
         <p:nvSpPr>
@@ -3432,6 +3501,13 @@
           </a:solidFill>
           <a:ln/>
         </p:spPr>
+        <p:txBody>
+          <a:bodyPr/>
+          <a:lstStyle/>
+          <a:p>
+            <a:endParaRPr lang="de-DE"/>
+          </a:p>
+        </p:txBody>
       </p:sp>
       <p:sp>
         <p:nvSpPr>
@@ -3454,7 +3530,7 @@
           <a:bodyPr wrap="square" rtlCol="0" anchor="ctr"/>
           <a:lstStyle/>
           <a:p>
-            <a:pPr indent="0" marL="0">
+            <a:pPr marL="0" indent="0">
               <a:buNone/>
             </a:pPr>
             <a:r>
@@ -3493,7 +3569,7 @@
           <a:bodyPr wrap="square" rtlCol="0" anchor="ctr"/>
           <a:lstStyle/>
           <a:p>
-            <a:pPr indent="0" marL="0">
+            <a:pPr marL="0" indent="0">
               <a:buNone/>
             </a:pPr>
             <a:r>
@@ -3532,7 +3608,7 @@
           <a:bodyPr wrap="square" rtlCol="0" anchor="ctr"/>
           <a:lstStyle/>
           <a:p>
-            <a:pPr indent="0" marL="0">
+            <a:pPr marL="0" indent="0">
               <a:buNone/>
             </a:pPr>
             <a:r>
@@ -3546,9 +3622,6 @@
               </a:rPr>
               <a:t>Source: </a:t>
             </a:r>
-            <a:pPr indent="0" marL="0">
-              <a:buNone/>
-            </a:pPr>
             <a:r>
               <a:rPr lang="en-US" sz="1300" dirty="0">
                 <a:solidFill>
@@ -3585,7 +3658,7 @@
           <a:bodyPr wrap="square" rtlCol="0" anchor="ctr"/>
           <a:lstStyle/>
           <a:p>
-            <a:pPr indent="0" marL="0">
+            <a:pPr marL="0" indent="0">
               <a:buNone/>
             </a:pPr>
             <a:r>
@@ -3624,7 +3697,7 @@
           <a:bodyPr wrap="square" rtlCol="0" anchor="ctr"/>
           <a:lstStyle/>
           <a:p>
-            <a:pPr indent="0" marL="0">
+            <a:pPr marL="0" indent="0">
               <a:buNone/>
             </a:pPr>
             <a:r>
@@ -3663,7 +3736,7 @@
           <a:bodyPr wrap="square" rtlCol="0" anchor="ctr"/>
           <a:lstStyle/>
           <a:p>
-            <a:pPr algn="r" indent="0" marL="0">
+            <a:pPr marL="0" indent="0" algn="r">
               <a:buNone/>
             </a:pPr>
             <a:r>
@@ -3697,6 +3770,7 @@
         <a:solidFill>
           <a:srgbClr val="FFFFFF"/>
         </a:solidFill>
+        <a:effectLst/>
       </p:bgPr>
     </p:bg>
     <p:spTree>
@@ -3732,6 +3806,13 @@
           </a:solidFill>
           <a:ln/>
         </p:spPr>
+        <p:txBody>
+          <a:bodyPr/>
+          <a:lstStyle/>
+          <a:p>
+            <a:endParaRPr lang="de-DE"/>
+          </a:p>
+        </p:txBody>
       </p:sp>
       <p:sp>
         <p:nvSpPr>
@@ -3754,11 +3835,11 @@
           <a:bodyPr wrap="square" rtlCol="0" anchor="ctr"/>
           <a:lstStyle/>
           <a:p>
-            <a:pPr indent="0" marL="0">
-              <a:buNone/>
-            </a:pPr>
-            <a:r>
-              <a:rPr lang="en-US" sz="1300" b="1" spc="200" kern="0" dirty="0">
+            <a:pPr marL="0" indent="0">
+              <a:buNone/>
+            </a:pPr>
+            <a:r>
+              <a:rPr lang="en-US" sz="1300" b="1" kern="0" spc="200" dirty="0">
                 <a:solidFill>
                   <a:srgbClr val="0072B2"/>
                 </a:solidFill>
@@ -3793,7 +3874,7 @@
           <a:bodyPr wrap="square" rtlCol="0" anchor="ctr"/>
           <a:lstStyle/>
           <a:p>
-            <a:pPr indent="0" marL="0">
+            <a:pPr marL="0" indent="0">
               <a:buNone/>
             </a:pPr>
             <a:r>
@@ -3811,186 +3892,192 @@
           </a:p>
         </p:txBody>
       </p:sp>
+      <p:sp>
+        <p:nvSpPr>
+          <p:cNvPr id="6" name="Text 3"/>
+          <p:cNvSpPr/>
+          <p:nvPr/>
+        </p:nvSpPr>
+        <p:spPr>
+          <a:xfrm>
+            <a:off x="8046720" y="1645920"/>
+            <a:ext cx="3657600" cy="320040"/>
+          </a:xfrm>
+          <a:prstGeom prst="rect">
+            <a:avLst/>
+          </a:prstGeom>
+          <a:noFill/>
+          <a:ln/>
+        </p:spPr>
+        <p:txBody>
+          <a:bodyPr wrap="square" rtlCol="0" anchor="ctr"/>
+          <a:lstStyle/>
+          <a:p>
+            <a:pPr marL="0" indent="0">
+              <a:buNone/>
+            </a:pPr>
+            <a:r>
+              <a:rPr lang="en-US" sz="1200" b="1" kern="0" spc="100" dirty="0">
+                <a:solidFill>
+                  <a:srgbClr val="D55E00"/>
+                </a:solidFill>
+                <a:latin typeface="Calibri" pitchFamily="34" charset="0"/>
+                <a:ea typeface="Calibri" pitchFamily="34" charset="-122"/>
+                <a:cs typeface="Calibri" pitchFamily="34" charset="-120"/>
+              </a:rPr>
+              <a:t>Takeaway</a:t>
+            </a:r>
+            <a:endParaRPr lang="en-US" sz="1200" dirty="0"/>
+          </a:p>
+        </p:txBody>
+      </p:sp>
+      <p:sp>
+        <p:nvSpPr>
+          <p:cNvPr id="7" name="Text 4"/>
+          <p:cNvSpPr/>
+          <p:nvPr/>
+        </p:nvSpPr>
+        <p:spPr>
+          <a:xfrm>
+            <a:off x="8046720" y="2011680"/>
+            <a:ext cx="3657600" cy="1645920"/>
+          </a:xfrm>
+          <a:prstGeom prst="rect">
+            <a:avLst/>
+          </a:prstGeom>
+          <a:noFill/>
+          <a:ln/>
+        </p:spPr>
+        <p:txBody>
+          <a:bodyPr wrap="square" rtlCol="0" anchor="ctr"/>
+          <a:lstStyle/>
+          <a:p>
+            <a:pPr marL="0" indent="0">
+              <a:buNone/>
+            </a:pPr>
+            <a:r>
+              <a:rPr lang="en-US" sz="1300" dirty="0">
+                <a:solidFill>
+                  <a:srgbClr val="3A4152"/>
+                </a:solidFill>
+                <a:latin typeface="Calibri" pitchFamily="34" charset="0"/>
+                <a:ea typeface="Calibri" pitchFamily="34" charset="-122"/>
+                <a:cs typeface="Calibri" pitchFamily="34" charset="-120"/>
+              </a:rPr>
+              <a:t>Northern/Northeastern states average 15–21+ day deliveries and sit visibly below the national review average — the South-East core (SP/PR/MG) delivers fastest and rates highest.</a:t>
+            </a:r>
+            <a:endParaRPr lang="en-US" sz="1300" dirty="0"/>
+          </a:p>
+        </p:txBody>
+      </p:sp>
+      <p:sp>
+        <p:nvSpPr>
+          <p:cNvPr id="8" name="Text 5"/>
+          <p:cNvSpPr/>
+          <p:nvPr/>
+        </p:nvSpPr>
+        <p:spPr>
+          <a:xfrm>
+            <a:off x="457200" y="6537960"/>
+            <a:ext cx="7315200" cy="274320"/>
+          </a:xfrm>
+          <a:prstGeom prst="rect">
+            <a:avLst/>
+          </a:prstGeom>
+          <a:noFill/>
+          <a:ln/>
+        </p:spPr>
+        <p:txBody>
+          <a:bodyPr wrap="square" rtlCol="0" anchor="ctr"/>
+          <a:lstStyle/>
+          <a:p>
+            <a:pPr marL="0" indent="0">
+              <a:buNone/>
+            </a:pPr>
+            <a:r>
+              <a:rPr lang="en-US" sz="900" dirty="0">
+                <a:solidFill>
+                  <a:srgbClr val="8A93A6"/>
+                </a:solidFill>
+                <a:latin typeface="Calibri" pitchFamily="34" charset="0"/>
+                <a:ea typeface="Calibri" pitchFamily="34" charset="-122"/>
+                <a:cs typeface="Calibri" pitchFamily="34" charset="-120"/>
+              </a:rPr>
+              <a:t>Brazil's Marketplace in Motion  ·  Data Visualization Final Project</a:t>
+            </a:r>
+            <a:endParaRPr lang="en-US" sz="900" dirty="0"/>
+          </a:p>
+        </p:txBody>
+      </p:sp>
+      <p:sp>
+        <p:nvSpPr>
+          <p:cNvPr id="9" name="Text 6"/>
+          <p:cNvSpPr/>
+          <p:nvPr/>
+        </p:nvSpPr>
+        <p:spPr>
+          <a:xfrm>
+            <a:off x="11521440" y="6537960"/>
+            <a:ext cx="457200" cy="274320"/>
+          </a:xfrm>
+          <a:prstGeom prst="rect">
+            <a:avLst/>
+          </a:prstGeom>
+          <a:noFill/>
+          <a:ln/>
+        </p:spPr>
+        <p:txBody>
+          <a:bodyPr wrap="square" rtlCol="0" anchor="ctr"/>
+          <a:lstStyle/>
+          <a:p>
+            <a:pPr marL="0" indent="0" algn="r">
+              <a:buNone/>
+            </a:pPr>
+            <a:r>
+              <a:rPr lang="en-US" sz="900" dirty="0">
+                <a:solidFill>
+                  <a:srgbClr val="8A93A6"/>
+                </a:solidFill>
+                <a:latin typeface="Calibri" pitchFamily="34" charset="0"/>
+                <a:ea typeface="Calibri" pitchFamily="34" charset="-122"/>
+                <a:cs typeface="Calibri" pitchFamily="34" charset="-120"/>
+              </a:rPr>
+              <a:t>3</a:t>
+            </a:r>
+            <a:endParaRPr lang="en-US" sz="900" dirty="0"/>
+          </a:p>
+        </p:txBody>
+      </p:sp>
       <p:pic>
         <p:nvPicPr>
-          <p:cNvPr id="5" name="Image 0" descr="/home/claude/project/deck/assets/q1.png">    </p:cNvPr>
+          <p:cNvPr id="11" name="Picture 10">
+            <a:extLst>
+              <a:ext uri="{FF2B5EF4-FFF2-40B4-BE49-F238E27FC236}">
+                <a16:creationId xmlns:a16="http://schemas.microsoft.com/office/drawing/2014/main" id="{A7943774-7EB2-CA05-94DA-92048183ACBF}"/>
+              </a:ext>
+            </a:extLst>
+          </p:cNvPr>
           <p:cNvPicPr>
             <a:picLocks noChangeAspect="1"/>
           </p:cNvPicPr>
           <p:nvPr/>
         </p:nvPicPr>
         <p:blipFill>
-          <a:blip r:embed="rId1"/>
+          <a:blip r:embed="rId3"/>
           <a:stretch>
             <a:fillRect/>
           </a:stretch>
         </p:blipFill>
         <p:spPr>
           <a:xfrm>
-            <a:off x="457200" y="1508760"/>
-            <a:ext cx="7315200" cy="3904488"/>
+            <a:off x="401268" y="1550694"/>
+            <a:ext cx="7645452" cy="4247473"/>
           </a:xfrm>
           <a:prstGeom prst="rect">
             <a:avLst/>
           </a:prstGeom>
         </p:spPr>
       </p:pic>
-      <p:sp>
-        <p:nvSpPr>
-          <p:cNvPr id="6" name="Text 3"/>
-          <p:cNvSpPr/>
-          <p:nvPr/>
-        </p:nvSpPr>
-        <p:spPr>
-          <a:xfrm>
-            <a:off x="8046720" y="1645920"/>
-            <a:ext cx="3657600" cy="320040"/>
-          </a:xfrm>
-          <a:prstGeom prst="rect">
-            <a:avLst/>
-          </a:prstGeom>
-          <a:noFill/>
-          <a:ln/>
-        </p:spPr>
-        <p:txBody>
-          <a:bodyPr wrap="square" rtlCol="0" anchor="ctr"/>
-          <a:lstStyle/>
-          <a:p>
-            <a:pPr indent="0" marL="0">
-              <a:buNone/>
-            </a:pPr>
-            <a:r>
-              <a:rPr lang="en-US" sz="1200" b="1" spc="100" kern="0" dirty="0">
-                <a:solidFill>
-                  <a:srgbClr val="D55E00"/>
-                </a:solidFill>
-                <a:latin typeface="Calibri" pitchFamily="34" charset="0"/>
-                <a:ea typeface="Calibri" pitchFamily="34" charset="-122"/>
-                <a:cs typeface="Calibri" pitchFamily="34" charset="-120"/>
-              </a:rPr>
-              <a:t>Takeaway</a:t>
-            </a:r>
-            <a:endParaRPr lang="en-US" sz="1200" dirty="0"/>
-          </a:p>
-        </p:txBody>
-      </p:sp>
-      <p:sp>
-        <p:nvSpPr>
-          <p:cNvPr id="7" name="Text 4"/>
-          <p:cNvSpPr/>
-          <p:nvPr/>
-        </p:nvSpPr>
-        <p:spPr>
-          <a:xfrm>
-            <a:off x="8046720" y="2011680"/>
-            <a:ext cx="3657600" cy="1645920"/>
-          </a:xfrm>
-          <a:prstGeom prst="rect">
-            <a:avLst/>
-          </a:prstGeom>
-          <a:noFill/>
-          <a:ln/>
-        </p:spPr>
-        <p:txBody>
-          <a:bodyPr wrap="square" rtlCol="0" anchor="ctr"/>
-          <a:lstStyle/>
-          <a:p>
-            <a:pPr indent="0" marL="0">
-              <a:buNone/>
-            </a:pPr>
-            <a:r>
-              <a:rPr lang="en-US" sz="1300" dirty="0">
-                <a:solidFill>
-                  <a:srgbClr val="3A4152"/>
-                </a:solidFill>
-                <a:latin typeface="Calibri" pitchFamily="34" charset="0"/>
-                <a:ea typeface="Calibri" pitchFamily="34" charset="-122"/>
-                <a:cs typeface="Calibri" pitchFamily="34" charset="-120"/>
-              </a:rPr>
-              <a:t>Northern/Northeastern states average 15–21+ day deliveries and sit visibly below the national review average — the South-East core (SP/PR/MG) delivers fastest and rates highest.</a:t>
-            </a:r>
-            <a:endParaRPr lang="en-US" sz="1300" dirty="0"/>
-          </a:p>
-        </p:txBody>
-      </p:sp>
-      <p:sp>
-        <p:nvSpPr>
-          <p:cNvPr id="8" name="Text 5"/>
-          <p:cNvSpPr/>
-          <p:nvPr/>
-        </p:nvSpPr>
-        <p:spPr>
-          <a:xfrm>
-            <a:off x="457200" y="6537960"/>
-            <a:ext cx="7315200" cy="274320"/>
-          </a:xfrm>
-          <a:prstGeom prst="rect">
-            <a:avLst/>
-          </a:prstGeom>
-          <a:noFill/>
-          <a:ln/>
-        </p:spPr>
-        <p:txBody>
-          <a:bodyPr wrap="square" rtlCol="0" anchor="ctr"/>
-          <a:lstStyle/>
-          <a:p>
-            <a:pPr indent="0" marL="0">
-              <a:buNone/>
-            </a:pPr>
-            <a:r>
-              <a:rPr lang="en-US" sz="900" dirty="0">
-                <a:solidFill>
-                  <a:srgbClr val="8A93A6"/>
-                </a:solidFill>
-                <a:latin typeface="Calibri" pitchFamily="34" charset="0"/>
-                <a:ea typeface="Calibri" pitchFamily="34" charset="-122"/>
-                <a:cs typeface="Calibri" pitchFamily="34" charset="-120"/>
-              </a:rPr>
-              <a:t>Brazil's Marketplace in Motion  ·  Data Visualization Final Project</a:t>
-            </a:r>
-            <a:endParaRPr lang="en-US" sz="900" dirty="0"/>
-          </a:p>
-        </p:txBody>
-      </p:sp>
-      <p:sp>
-        <p:nvSpPr>
-          <p:cNvPr id="9" name="Text 6"/>
-          <p:cNvSpPr/>
-          <p:nvPr/>
-        </p:nvSpPr>
-        <p:spPr>
-          <a:xfrm>
-            <a:off x="11521440" y="6537960"/>
-            <a:ext cx="457200" cy="274320"/>
-          </a:xfrm>
-          <a:prstGeom prst="rect">
-            <a:avLst/>
-          </a:prstGeom>
-          <a:noFill/>
-          <a:ln/>
-        </p:spPr>
-        <p:txBody>
-          <a:bodyPr wrap="square" rtlCol="0" anchor="ctr"/>
-          <a:lstStyle/>
-          <a:p>
-            <a:pPr algn="r" indent="0" marL="0">
-              <a:buNone/>
-            </a:pPr>
-            <a:r>
-              <a:rPr lang="en-US" sz="900" dirty="0">
-                <a:solidFill>
-                  <a:srgbClr val="8A93A6"/>
-                </a:solidFill>
-                <a:latin typeface="Calibri" pitchFamily="34" charset="0"/>
-                <a:ea typeface="Calibri" pitchFamily="34" charset="-122"/>
-                <a:cs typeface="Calibri" pitchFamily="34" charset="-120"/>
-              </a:rPr>
-              <a:t>3</a:t>
-            </a:r>
-            <a:endParaRPr lang="en-US" sz="900" dirty="0"/>
-          </a:p>
-        </p:txBody>
-      </p:sp>
     </p:spTree>
   </p:cSld>
   <p:clrMapOvr>
@@ -4007,6 +4094,7 @@
         <a:solidFill>
           <a:srgbClr val="FFFFFF"/>
         </a:solidFill>
+        <a:effectLst/>
       </p:bgPr>
     </p:bg>
     <p:spTree>
@@ -4042,6 +4130,13 @@
           </a:solidFill>
           <a:ln/>
         </p:spPr>
+        <p:txBody>
+          <a:bodyPr/>
+          <a:lstStyle/>
+          <a:p>
+            <a:endParaRPr lang="de-DE"/>
+          </a:p>
+        </p:txBody>
       </p:sp>
       <p:sp>
         <p:nvSpPr>
@@ -4064,11 +4159,11 @@
           <a:bodyPr wrap="square" rtlCol="0" anchor="ctr"/>
           <a:lstStyle/>
           <a:p>
-            <a:pPr indent="0" marL="0">
-              <a:buNone/>
-            </a:pPr>
-            <a:r>
-              <a:rPr lang="en-US" sz="1300" b="1" spc="200" kern="0" dirty="0">
+            <a:pPr marL="0" indent="0">
+              <a:buNone/>
+            </a:pPr>
+            <a:r>
+              <a:rPr lang="en-US" sz="1300" b="1" kern="0" spc="200" dirty="0">
                 <a:solidFill>
                   <a:srgbClr val="0072B2"/>
                 </a:solidFill>
@@ -4103,7 +4198,7 @@
           <a:bodyPr wrap="square" rtlCol="0" anchor="ctr"/>
           <a:lstStyle/>
           <a:p>
-            <a:pPr indent="0" marL="0">
+            <a:pPr marL="0" indent="0">
               <a:buNone/>
             </a:pPr>
             <a:r>
@@ -4123,22 +4218,21 @@
       </p:sp>
       <p:pic>
         <p:nvPicPr>
-          <p:cNvPr id="5" name="Image 0" descr="/home/claude/project/deck/assets/q4.png">    </p:cNvPr>
+          <p:cNvPr id="5" name="Image 0"/>
           <p:cNvPicPr>
             <a:picLocks noChangeAspect="1"/>
           </p:cNvPicPr>
           <p:nvPr/>
         </p:nvPicPr>
         <p:blipFill>
-          <a:blip r:embed="rId1"/>
-          <a:stretch>
-            <a:fillRect/>
-          </a:stretch>
+          <a:blip r:embed="rId3"/>
+          <a:srcRect/>
+          <a:stretch/>
         </p:blipFill>
         <p:spPr>
           <a:xfrm>
-            <a:off x="457200" y="1508760"/>
-            <a:ext cx="7315200" cy="3904488"/>
+            <a:off x="539496" y="1710267"/>
+            <a:ext cx="7315200" cy="3894666"/>
           </a:xfrm>
           <a:prstGeom prst="rect">
             <a:avLst/>
@@ -4166,11 +4260,11 @@
           <a:bodyPr wrap="square" rtlCol="0" anchor="ctr"/>
           <a:lstStyle/>
           <a:p>
-            <a:pPr indent="0" marL="0">
-              <a:buNone/>
-            </a:pPr>
-            <a:r>
-              <a:rPr lang="en-US" sz="1200" b="1" spc="100" kern="0" dirty="0">
+            <a:pPr marL="0" indent="0">
+              <a:buNone/>
+            </a:pPr>
+            <a:r>
+              <a:rPr lang="en-US" sz="1200" b="1" kern="0" spc="100" dirty="0">
                 <a:solidFill>
                   <a:srgbClr val="D55E00"/>
                 </a:solidFill>
@@ -4205,7 +4299,7 @@
           <a:bodyPr wrap="square" rtlCol="0" anchor="ctr"/>
           <a:lstStyle/>
           <a:p>
-            <a:pPr indent="0" marL="0">
+            <a:pPr marL="0" indent="0">
               <a:buNone/>
             </a:pPr>
             <a:r>
@@ -4244,7 +4338,7 @@
           <a:bodyPr wrap="square" rtlCol="0" anchor="ctr"/>
           <a:lstStyle/>
           <a:p>
-            <a:pPr indent="0" marL="0">
+            <a:pPr marL="0" indent="0">
               <a:buNone/>
             </a:pPr>
             <a:r>
@@ -4283,7 +4377,7 @@
           <a:bodyPr wrap="square" rtlCol="0" anchor="ctr"/>
           <a:lstStyle/>
           <a:p>
-            <a:pPr algn="r" indent="0" marL="0">
+            <a:pPr marL="0" indent="0" algn="r">
               <a:buNone/>
             </a:pPr>
             <a:r>
@@ -4317,6 +4411,7 @@
         <a:solidFill>
           <a:srgbClr val="FFFFFF"/>
         </a:solidFill>
+        <a:effectLst/>
       </p:bgPr>
     </p:bg>
     <p:spTree>
@@ -4352,6 +4447,13 @@
           </a:solidFill>
           <a:ln/>
         </p:spPr>
+        <p:txBody>
+          <a:bodyPr/>
+          <a:lstStyle/>
+          <a:p>
+            <a:endParaRPr lang="de-DE"/>
+          </a:p>
+        </p:txBody>
       </p:sp>
       <p:sp>
         <p:nvSpPr>
@@ -4374,11 +4476,11 @@
           <a:bodyPr wrap="square" rtlCol="0" anchor="ctr"/>
           <a:lstStyle/>
           <a:p>
-            <a:pPr indent="0" marL="0">
-              <a:buNone/>
-            </a:pPr>
-            <a:r>
-              <a:rPr lang="en-US" sz="1300" b="1" spc="200" kern="0" dirty="0">
+            <a:pPr marL="0" indent="0">
+              <a:buNone/>
+            </a:pPr>
+            <a:r>
+              <a:rPr lang="en-US" sz="1300" b="1" kern="0" spc="200" dirty="0">
                 <a:solidFill>
                   <a:srgbClr val="0072B2"/>
                 </a:solidFill>
@@ -4413,7 +4515,7 @@
           <a:bodyPr wrap="square" rtlCol="0" anchor="ctr"/>
           <a:lstStyle/>
           <a:p>
-            <a:pPr indent="0" marL="0">
+            <a:pPr marL="0" indent="0">
               <a:buNone/>
             </a:pPr>
             <a:r>
@@ -4433,22 +4535,21 @@
       </p:sp>
       <p:pic>
         <p:nvPicPr>
-          <p:cNvPr id="5" name="Image 0" descr="/home/claude/project/deck/assets/q9.png">    </p:cNvPr>
+          <p:cNvPr id="5" name="Image 0"/>
           <p:cNvPicPr>
             <a:picLocks noChangeAspect="1"/>
           </p:cNvPicPr>
           <p:nvPr/>
         </p:nvPicPr>
         <p:blipFill>
-          <a:blip r:embed="rId1"/>
-          <a:stretch>
-            <a:fillRect/>
-          </a:stretch>
+          <a:blip r:embed="rId3"/>
+          <a:srcRect/>
+          <a:stretch/>
         </p:blipFill>
         <p:spPr>
           <a:xfrm>
-            <a:off x="457200" y="1508760"/>
-            <a:ext cx="7315200" cy="3904488"/>
+            <a:off x="539496" y="1645920"/>
+            <a:ext cx="7028078" cy="3904488"/>
           </a:xfrm>
           <a:prstGeom prst="rect">
             <a:avLst/>
@@ -4476,11 +4577,11 @@
           <a:bodyPr wrap="square" rtlCol="0" anchor="ctr"/>
           <a:lstStyle/>
           <a:p>
-            <a:pPr indent="0" marL="0">
-              <a:buNone/>
-            </a:pPr>
-            <a:r>
-              <a:rPr lang="en-US" sz="1200" b="1" spc="100" kern="0" dirty="0">
+            <a:pPr marL="0" indent="0">
+              <a:buNone/>
+            </a:pPr>
+            <a:r>
+              <a:rPr lang="en-US" sz="1200" b="1" kern="0" spc="100" dirty="0">
                 <a:solidFill>
                   <a:srgbClr val="D55E00"/>
                 </a:solidFill>
@@ -4515,7 +4616,7 @@
           <a:bodyPr wrap="square" rtlCol="0" anchor="ctr"/>
           <a:lstStyle/>
           <a:p>
-            <a:pPr indent="0" marL="0">
+            <a:pPr marL="0" indent="0">
               <a:buNone/>
             </a:pPr>
             <a:r>
@@ -4554,7 +4655,7 @@
           <a:bodyPr wrap="square" rtlCol="0" anchor="ctr"/>
           <a:lstStyle/>
           <a:p>
-            <a:pPr indent="0" marL="0">
+            <a:pPr marL="0" indent="0">
               <a:buNone/>
             </a:pPr>
             <a:r>
@@ -4593,7 +4694,7 @@
           <a:bodyPr wrap="square" rtlCol="0" anchor="ctr"/>
           <a:lstStyle/>
           <a:p>
-            <a:pPr algn="r" indent="0" marL="0">
+            <a:pPr marL="0" indent="0" algn="r">
               <a:buNone/>
             </a:pPr>
             <a:r>
@@ -4627,6 +4728,7 @@
         <a:solidFill>
           <a:srgbClr val="FFFFFF"/>
         </a:solidFill>
+        <a:effectLst/>
       </p:bgPr>
     </p:bg>
     <p:spTree>
@@ -4662,6 +4764,13 @@
           </a:solidFill>
           <a:ln/>
         </p:spPr>
+        <p:txBody>
+          <a:bodyPr/>
+          <a:lstStyle/>
+          <a:p>
+            <a:endParaRPr lang="de-DE"/>
+          </a:p>
+        </p:txBody>
       </p:sp>
       <p:sp>
         <p:nvSpPr>
@@ -4684,11 +4793,11 @@
           <a:bodyPr wrap="square" rtlCol="0" anchor="ctr"/>
           <a:lstStyle/>
           <a:p>
-            <a:pPr indent="0" marL="0">
-              <a:buNone/>
-            </a:pPr>
-            <a:r>
-              <a:rPr lang="en-US" sz="1300" b="1" spc="200" kern="0" dirty="0">
+            <a:pPr marL="0" indent="0">
+              <a:buNone/>
+            </a:pPr>
+            <a:r>
+              <a:rPr lang="en-US" sz="1300" b="1" kern="0" spc="200" dirty="0">
                 <a:solidFill>
                   <a:srgbClr val="0072B2"/>
                 </a:solidFill>
@@ -4723,7 +4832,7 @@
           <a:bodyPr wrap="square" rtlCol="0" anchor="ctr"/>
           <a:lstStyle/>
           <a:p>
-            <a:pPr indent="0" marL="0">
+            <a:pPr marL="0" indent="0">
               <a:buNone/>
             </a:pPr>
             <a:r>
@@ -4743,22 +4852,21 @@
       </p:sp>
       <p:pic>
         <p:nvPicPr>
-          <p:cNvPr id="5" name="Image 0" descr="/home/claude/project/deck/assets/q6.png">    </p:cNvPr>
+          <p:cNvPr id="5" name="Image 0"/>
           <p:cNvPicPr>
             <a:picLocks noChangeAspect="1"/>
           </p:cNvPicPr>
           <p:nvPr/>
         </p:nvPicPr>
         <p:blipFill>
-          <a:blip r:embed="rId1"/>
-          <a:stretch>
-            <a:fillRect/>
-          </a:stretch>
+          <a:blip r:embed="rId3"/>
+          <a:srcRect/>
+          <a:stretch/>
         </p:blipFill>
         <p:spPr>
           <a:xfrm>
-            <a:off x="320040" y="1554480"/>
-            <a:ext cx="5806440" cy="3054096"/>
+            <a:off x="474574" y="1554480"/>
+            <a:ext cx="5497372" cy="3054096"/>
           </a:xfrm>
           <a:prstGeom prst="rect">
             <a:avLst/>
@@ -4767,22 +4875,21 @@
       </p:pic>
       <p:pic>
         <p:nvPicPr>
-          <p:cNvPr id="6" name="Image 1" descr="/home/claude/project/deck/assets/q3.png">    </p:cNvPr>
+          <p:cNvPr id="6" name="Image 1"/>
           <p:cNvPicPr>
             <a:picLocks noChangeAspect="1"/>
           </p:cNvPicPr>
           <p:nvPr/>
         </p:nvPicPr>
         <p:blipFill>
-          <a:blip r:embed="rId2"/>
-          <a:stretch>
-            <a:fillRect/>
-          </a:stretch>
+          <a:blip r:embed="rId4"/>
+          <a:srcRect/>
+          <a:stretch/>
         </p:blipFill>
         <p:spPr>
           <a:xfrm>
-            <a:off x="6263640" y="1554480"/>
-            <a:ext cx="5577840" cy="3127248"/>
+            <a:off x="6350618" y="1554480"/>
+            <a:ext cx="5403884" cy="3127248"/>
           </a:xfrm>
           <a:prstGeom prst="rect">
             <a:avLst/>
@@ -4810,7 +4917,7 @@
           <a:bodyPr wrap="square" rtlCol="0" anchor="ctr"/>
           <a:lstStyle/>
           <a:p>
-            <a:pPr indent="0" marL="0">
+            <a:pPr marL="0" indent="0">
               <a:buNone/>
             </a:pPr>
             <a:r>
@@ -4849,7 +4956,7 @@
           <a:bodyPr wrap="square" rtlCol="0" anchor="ctr"/>
           <a:lstStyle/>
           <a:p>
-            <a:pPr indent="0" marL="0">
+            <a:pPr marL="0" indent="0">
               <a:buNone/>
             </a:pPr>
             <a:r>
@@ -4888,7 +4995,7 @@
           <a:bodyPr wrap="square" rtlCol="0" anchor="ctr"/>
           <a:lstStyle/>
           <a:p>
-            <a:pPr algn="r" indent="0" marL="0">
+            <a:pPr marL="0" indent="0" algn="r">
               <a:buNone/>
             </a:pPr>
             <a:r>
@@ -4922,6 +5029,7 @@
         <a:solidFill>
           <a:srgbClr val="FFFFFF"/>
         </a:solidFill>
+        <a:effectLst/>
       </p:bgPr>
     </p:bg>
     <p:spTree>
@@ -4957,6 +5065,13 @@
           </a:solidFill>
           <a:ln/>
         </p:spPr>
+        <p:txBody>
+          <a:bodyPr/>
+          <a:lstStyle/>
+          <a:p>
+            <a:endParaRPr lang="de-DE"/>
+          </a:p>
+        </p:txBody>
       </p:sp>
       <p:sp>
         <p:nvSpPr>
@@ -4979,11 +5094,11 @@
           <a:bodyPr wrap="square" rtlCol="0" anchor="ctr"/>
           <a:lstStyle/>
           <a:p>
-            <a:pPr indent="0" marL="0">
-              <a:buNone/>
-            </a:pPr>
-            <a:r>
-              <a:rPr lang="en-US" sz="1300" b="1" spc="200" kern="0" dirty="0">
+            <a:pPr marL="0" indent="0">
+              <a:buNone/>
+            </a:pPr>
+            <a:r>
+              <a:rPr lang="en-US" sz="1300" b="1" kern="0" spc="200" dirty="0">
                 <a:solidFill>
                   <a:srgbClr val="0072B2"/>
                 </a:solidFill>
@@ -5018,7 +5133,7 @@
           <a:bodyPr wrap="square" rtlCol="0" anchor="ctr"/>
           <a:lstStyle/>
           <a:p>
-            <a:pPr indent="0" marL="0">
+            <a:pPr marL="0" indent="0">
               <a:buNone/>
             </a:pPr>
             <a:r>
@@ -5038,22 +5153,21 @@
       </p:sp>
       <p:pic>
         <p:nvPicPr>
-          <p:cNvPr id="5" name="Image 0" descr="/home/claude/project/deck/assets/q2.png">    </p:cNvPr>
+          <p:cNvPr id="5" name="Image 0"/>
           <p:cNvPicPr>
             <a:picLocks noChangeAspect="1"/>
           </p:cNvPicPr>
           <p:nvPr/>
         </p:nvPicPr>
         <p:blipFill>
-          <a:blip r:embed="rId1"/>
-          <a:stretch>
-            <a:fillRect/>
-          </a:stretch>
+          <a:blip r:embed="rId3"/>
+          <a:srcRect/>
+          <a:stretch/>
         </p:blipFill>
         <p:spPr>
           <a:xfrm>
-            <a:off x="320040" y="1554480"/>
-            <a:ext cx="6035040" cy="3054096"/>
+            <a:off x="588874" y="1554480"/>
+            <a:ext cx="5497372" cy="3054096"/>
           </a:xfrm>
           <a:prstGeom prst="rect">
             <a:avLst/>
@@ -5062,22 +5176,21 @@
       </p:pic>
       <p:pic>
         <p:nvPicPr>
-          <p:cNvPr id="6" name="Image 1" descr="/home/claude/project/deck/assets/q7.png">    </p:cNvPr>
+          <p:cNvPr id="6" name="Image 1"/>
           <p:cNvPicPr>
             <a:picLocks noChangeAspect="1"/>
           </p:cNvPicPr>
           <p:nvPr/>
         </p:nvPicPr>
         <p:blipFill>
-          <a:blip r:embed="rId2"/>
-          <a:stretch>
-            <a:fillRect/>
-          </a:stretch>
+          <a:blip r:embed="rId4"/>
+          <a:srcRect/>
+          <a:stretch/>
         </p:blipFill>
         <p:spPr>
           <a:xfrm>
-            <a:off x="6492240" y="1554480"/>
-            <a:ext cx="5349240" cy="3054096"/>
+            <a:off x="6492240" y="1657540"/>
+            <a:ext cx="5349240" cy="2847975"/>
           </a:xfrm>
           <a:prstGeom prst="rect">
             <a:avLst/>
@@ -5105,7 +5218,7 @@
           <a:bodyPr wrap="square" rtlCol="0" anchor="ctr"/>
           <a:lstStyle/>
           <a:p>
-            <a:pPr indent="0" marL="0">
+            <a:pPr marL="0" indent="0">
               <a:buNone/>
             </a:pPr>
             <a:r>
@@ -5144,7 +5257,7 @@
           <a:bodyPr wrap="square" rtlCol="0" anchor="ctr"/>
           <a:lstStyle/>
           <a:p>
-            <a:pPr indent="0" marL="0">
+            <a:pPr marL="0" indent="0">
               <a:buNone/>
             </a:pPr>
             <a:r>
@@ -5183,7 +5296,7 @@
           <a:bodyPr wrap="square" rtlCol="0" anchor="ctr"/>
           <a:lstStyle/>
           <a:p>
-            <a:pPr algn="r" indent="0" marL="0">
+            <a:pPr marL="0" indent="0" algn="r">
               <a:buNone/>
             </a:pPr>
             <a:r>
@@ -5217,6 +5330,7 @@
         <a:solidFill>
           <a:srgbClr val="FFFFFF"/>
         </a:solidFill>
+        <a:effectLst/>
       </p:bgPr>
     </p:bg>
     <p:spTree>
@@ -5252,6 +5366,13 @@
           </a:solidFill>
           <a:ln/>
         </p:spPr>
+        <p:txBody>
+          <a:bodyPr/>
+          <a:lstStyle/>
+          <a:p>
+            <a:endParaRPr lang="de-DE"/>
+          </a:p>
+        </p:txBody>
       </p:sp>
       <p:sp>
         <p:nvSpPr>
@@ -5274,11 +5395,11 @@
           <a:bodyPr wrap="square" rtlCol="0" anchor="ctr"/>
           <a:lstStyle/>
           <a:p>
-            <a:pPr indent="0" marL="0">
-              <a:buNone/>
-            </a:pPr>
-            <a:r>
-              <a:rPr lang="en-US" sz="1300" b="1" spc="200" kern="0" dirty="0">
+            <a:pPr marL="0" indent="0">
+              <a:buNone/>
+            </a:pPr>
+            <a:r>
+              <a:rPr lang="en-US" sz="1300" b="1" kern="0" spc="200" dirty="0">
                 <a:solidFill>
                   <a:srgbClr val="0072B2"/>
                 </a:solidFill>
@@ -5313,7 +5434,7 @@
           <a:bodyPr wrap="square" rtlCol="0" anchor="ctr"/>
           <a:lstStyle/>
           <a:p>
-            <a:pPr indent="0" marL="0">
+            <a:pPr marL="0" indent="0">
               <a:buNone/>
             </a:pPr>
             <a:r>
@@ -5333,22 +5454,21 @@
       </p:sp>
       <p:pic>
         <p:nvPicPr>
-          <p:cNvPr id="5" name="Image 0" descr="/home/claude/project/deck/assets/q5.png">    </p:cNvPr>
+          <p:cNvPr id="5" name="Image 0"/>
           <p:cNvPicPr>
             <a:picLocks noChangeAspect="1"/>
           </p:cNvPicPr>
           <p:nvPr/>
         </p:nvPicPr>
         <p:blipFill>
-          <a:blip r:embed="rId1"/>
-          <a:stretch>
-            <a:fillRect/>
-          </a:stretch>
+          <a:blip r:embed="rId3"/>
+          <a:srcRect/>
+          <a:stretch/>
         </p:blipFill>
         <p:spPr>
           <a:xfrm>
-            <a:off x="320040" y="1508760"/>
-            <a:ext cx="6035040" cy="3035808"/>
+            <a:off x="605333" y="1508760"/>
+            <a:ext cx="5464454" cy="3035808"/>
           </a:xfrm>
           <a:prstGeom prst="rect">
             <a:avLst/>
@@ -5357,22 +5477,21 @@
       </p:pic>
       <p:pic>
         <p:nvPicPr>
-          <p:cNvPr id="6" name="Image 1" descr="/home/claude/project/deck/assets/q12.png">    </p:cNvPr>
+          <p:cNvPr id="6" name="Image 1"/>
           <p:cNvPicPr>
             <a:picLocks noChangeAspect="1"/>
           </p:cNvPicPr>
           <p:nvPr/>
         </p:nvPicPr>
         <p:blipFill>
-          <a:blip r:embed="rId2"/>
-          <a:stretch>
-            <a:fillRect/>
-          </a:stretch>
+          <a:blip r:embed="rId4"/>
+          <a:srcRect/>
+          <a:stretch/>
         </p:blipFill>
         <p:spPr>
           <a:xfrm>
-            <a:off x="6492240" y="1508760"/>
-            <a:ext cx="5349240" cy="3035808"/>
+            <a:off x="6492240" y="1664589"/>
+            <a:ext cx="5349240" cy="2724150"/>
           </a:xfrm>
           <a:prstGeom prst="rect">
             <a:avLst/>
@@ -5400,7 +5519,7 @@
           <a:bodyPr wrap="square" rtlCol="0" anchor="ctr"/>
           <a:lstStyle/>
           <a:p>
-            <a:pPr indent="0" marL="0">
+            <a:pPr marL="0" indent="0">
               <a:buNone/>
             </a:pPr>
             <a:r>
@@ -5439,7 +5558,7 @@
           <a:bodyPr wrap="square" rtlCol="0" anchor="ctr"/>
           <a:lstStyle/>
           <a:p>
-            <a:pPr indent="0" marL="0">
+            <a:pPr marL="0" indent="0">
               <a:buNone/>
             </a:pPr>
             <a:r>
@@ -5478,7 +5597,7 @@
           <a:bodyPr wrap="square" rtlCol="0" anchor="ctr"/>
           <a:lstStyle/>
           <a:p>
-            <a:pPr algn="r" indent="0" marL="0">
+            <a:pPr marL="0" indent="0" algn="r">
               <a:buNone/>
             </a:pPr>
             <a:r>
@@ -5512,6 +5631,7 @@
         <a:solidFill>
           <a:srgbClr val="F5F1E8"/>
         </a:solidFill>
+        <a:effectLst/>
       </p:bgPr>
     </p:bg>
     <p:spTree>
@@ -5547,6 +5667,13 @@
           </a:solidFill>
           <a:ln/>
         </p:spPr>
+        <p:txBody>
+          <a:bodyPr/>
+          <a:lstStyle/>
+          <a:p>
+            <a:endParaRPr lang="de-DE"/>
+          </a:p>
+        </p:txBody>
       </p:sp>
       <p:sp>
         <p:nvSpPr>
@@ -5569,11 +5696,11 @@
           <a:bodyPr wrap="square" rtlCol="0" anchor="ctr"/>
           <a:lstStyle/>
           <a:p>
-            <a:pPr indent="0" marL="0">
-              <a:buNone/>
-            </a:pPr>
-            <a:r>
-              <a:rPr lang="en-US" sz="1300" b="1" spc="200" kern="0" dirty="0">
+            <a:pPr marL="0" indent="0">
+              <a:buNone/>
+            </a:pPr>
+            <a:r>
+              <a:rPr lang="en-US" sz="1300" b="1" kern="0" spc="200" dirty="0">
                 <a:solidFill>
                   <a:srgbClr val="0072B2"/>
                 </a:solidFill>
@@ -5608,7 +5735,7 @@
           <a:bodyPr wrap="square" rtlCol="0" anchor="ctr"/>
           <a:lstStyle/>
           <a:p>
-            <a:pPr indent="0" marL="0">
+            <a:pPr marL="0" indent="0">
               <a:buNone/>
             </a:pPr>
             <a:r>
@@ -5647,7 +5774,7 @@
           <a:bodyPr wrap="square" rtlCol="0" anchor="ctr"/>
           <a:lstStyle/>
           <a:p>
-            <a:pPr indent="0" marL="0">
+            <a:pPr marL="0" indent="0">
               <a:buNone/>
             </a:pPr>
             <a:r>
@@ -5691,6 +5818,13 @@
             <a:prstDash val="solid"/>
           </a:ln>
         </p:spPr>
+        <p:txBody>
+          <a:bodyPr/>
+          <a:lstStyle/>
+          <a:p>
+            <a:endParaRPr lang="de-DE"/>
+          </a:p>
+        </p:txBody>
       </p:sp>
       <p:sp>
         <p:nvSpPr>
@@ -5711,6 +5845,13 @@
           </a:solidFill>
           <a:ln/>
         </p:spPr>
+        <p:txBody>
+          <a:bodyPr/>
+          <a:lstStyle/>
+          <a:p>
+            <a:endParaRPr lang="de-DE" dirty="0"/>
+          </a:p>
+        </p:txBody>
       </p:sp>
       <p:sp>
         <p:nvSpPr>
@@ -5731,6 +5872,13 @@
           </a:solidFill>
           <a:ln/>
         </p:spPr>
+        <p:txBody>
+          <a:bodyPr/>
+          <a:lstStyle/>
+          <a:p>
+            <a:endParaRPr lang="de-DE"/>
+          </a:p>
+        </p:txBody>
       </p:sp>
       <p:sp>
         <p:nvSpPr>
@@ -5751,6 +5899,13 @@
           </a:solidFill>
           <a:ln/>
         </p:spPr>
+        <p:txBody>
+          <a:bodyPr/>
+          <a:lstStyle/>
+          <a:p>
+            <a:endParaRPr lang="de-DE"/>
+          </a:p>
+        </p:txBody>
       </p:sp>
       <p:sp>
         <p:nvSpPr>
@@ -5771,6 +5926,13 @@
           </a:solidFill>
           <a:ln/>
         </p:spPr>
+        <p:txBody>
+          <a:bodyPr/>
+          <a:lstStyle/>
+          <a:p>
+            <a:endParaRPr lang="de-DE"/>
+          </a:p>
+        </p:txBody>
       </p:sp>
       <p:sp>
         <p:nvSpPr>
@@ -5793,9 +5955,6 @@
           <a:bodyPr wrap="square" rtlCol="0" anchor="ctr"/>
           <a:lstStyle/>
           <a:p>
-            <a:pPr algn="l" indent="0" marL="0">
-              <a:buNone/>
-            </a:pPr>
             <a:r>
               <a:rPr lang="en-US" sz="1000" dirty="0">
                 <a:solidFill>
@@ -5805,7 +5964,7 @@
                 <a:ea typeface="Calibri" pitchFamily="34" charset="-122"/>
                 <a:cs typeface="Calibri" pitchFamily="34" charset="-120"/>
               </a:rPr>
-              <a:t>share.streamlit.io / olist-brazil-dashboard</a:t>
+              <a:t>https://brazilian-e-commerce-analysis-guilherme.streamlit.app/</a:t>
             </a:r>
             <a:endParaRPr lang="en-US" sz="1000" dirty="0"/>
           </a:p>
@@ -5813,22 +5972,21 @@
       </p:sp>
       <p:pic>
         <p:nvPicPr>
-          <p:cNvPr id="12" name="Image 0" descr="/home/claude/project/deck/assets/q4.png">    </p:cNvPr>
+          <p:cNvPr id="12" name="Image 0"/>
           <p:cNvPicPr>
             <a:picLocks noChangeAspect="1"/>
           </p:cNvPicPr>
           <p:nvPr/>
         </p:nvPicPr>
         <p:blipFill>
-          <a:blip r:embed="rId1"/>
-          <a:stretch>
-            <a:fillRect/>
-          </a:stretch>
+          <a:blip r:embed="rId3"/>
+          <a:srcRect/>
+          <a:stretch/>
         </p:blipFill>
         <p:spPr>
           <a:xfrm>
-            <a:off x="777240" y="2697480"/>
-            <a:ext cx="3291840" cy="1691640"/>
+            <a:off x="834489" y="2697480"/>
+            <a:ext cx="3177341" cy="1691640"/>
           </a:xfrm>
           <a:prstGeom prst="rect">
             <a:avLst/>
@@ -5837,22 +5995,21 @@
       </p:pic>
       <p:pic>
         <p:nvPicPr>
-          <p:cNvPr id="13" name="Image 1" descr="/home/claude/project/deck/assets/q1.png">    </p:cNvPr>
+          <p:cNvPr id="13" name="Image 1"/>
           <p:cNvPicPr>
             <a:picLocks noChangeAspect="1"/>
           </p:cNvPicPr>
           <p:nvPr/>
         </p:nvPicPr>
         <p:blipFill>
-          <a:blip r:embed="rId2"/>
-          <a:stretch>
-            <a:fillRect/>
-          </a:stretch>
+          <a:blip r:embed="rId4"/>
+          <a:srcRect/>
+          <a:stretch/>
         </p:blipFill>
         <p:spPr>
           <a:xfrm>
-            <a:off x="4206240" y="2697480"/>
-            <a:ext cx="3566160" cy="1691640"/>
+            <a:off x="4466844" y="2697480"/>
+            <a:ext cx="3044952" cy="1691640"/>
           </a:xfrm>
           <a:prstGeom prst="rect">
             <a:avLst/>
@@ -5861,22 +6018,21 @@
       </p:pic>
       <p:pic>
         <p:nvPicPr>
-          <p:cNvPr id="14" name="Image 2" descr="/home/claude/project/deck/assets/q9.png">    </p:cNvPr>
+          <p:cNvPr id="14" name="Image 2"/>
           <p:cNvPicPr>
             <a:picLocks noChangeAspect="1"/>
           </p:cNvPicPr>
           <p:nvPr/>
         </p:nvPicPr>
         <p:blipFill>
-          <a:blip r:embed="rId3"/>
-          <a:stretch>
-            <a:fillRect/>
-          </a:stretch>
+          <a:blip r:embed="rId5"/>
+          <a:srcRect/>
+          <a:stretch/>
         </p:blipFill>
         <p:spPr>
           <a:xfrm>
-            <a:off x="777240" y="4480560"/>
-            <a:ext cx="3291840" cy="1554480"/>
+            <a:off x="1024128" y="4480560"/>
+            <a:ext cx="2798064" cy="1554480"/>
           </a:xfrm>
           <a:prstGeom prst="rect">
             <a:avLst/>
@@ -5885,22 +6041,21 @@
       </p:pic>
       <p:pic>
         <p:nvPicPr>
-          <p:cNvPr id="15" name="Image 3" descr="/home/claude/project/deck/assets/q12.png">    </p:cNvPr>
+          <p:cNvPr id="15" name="Image 3"/>
           <p:cNvPicPr>
             <a:picLocks noChangeAspect="1"/>
           </p:cNvPicPr>
           <p:nvPr/>
         </p:nvPicPr>
         <p:blipFill>
-          <a:blip r:embed="rId4"/>
-          <a:stretch>
-            <a:fillRect/>
-          </a:stretch>
+          <a:blip r:embed="rId6"/>
+          <a:srcRect/>
+          <a:stretch/>
         </p:blipFill>
         <p:spPr>
           <a:xfrm>
-            <a:off x="4206240" y="4480560"/>
-            <a:ext cx="3566160" cy="1554480"/>
+            <a:off x="4463103" y="4480560"/>
+            <a:ext cx="3052433" cy="1554480"/>
           </a:xfrm>
           <a:prstGeom prst="rect">
             <a:avLst/>
@@ -5928,11 +6083,11 @@
           <a:bodyPr wrap="square" rtlCol="0" anchor="ctr"/>
           <a:lstStyle/>
           <a:p>
-            <a:pPr indent="0" marL="0">
-              <a:buNone/>
-            </a:pPr>
-            <a:r>
-              <a:rPr lang="en-US" sz="1200" b="1" spc="100" kern="0" dirty="0">
+            <a:pPr marL="0" indent="0">
+              <a:buNone/>
+            </a:pPr>
+            <a:r>
+              <a:rPr lang="en-US" sz="1200" b="1" kern="0" spc="100" dirty="0">
                 <a:solidFill>
                   <a:srgbClr val="0072B2"/>
                 </a:solidFill>
@@ -5967,7 +6122,7 @@
           <a:bodyPr wrap="square" rtlCol="0" anchor="ctr"/>
           <a:lstStyle/>
           <a:p>
-            <a:pPr indent="0" marL="0">
+            <a:pPr marL="0" indent="0">
               <a:buNone/>
             </a:pPr>
             <a:r>
@@ -6006,7 +6161,7 @@
           <a:bodyPr wrap="square" rtlCol="0" anchor="ctr"/>
           <a:lstStyle/>
           <a:p>
-            <a:pPr indent="0" marL="0">
+            <a:pPr marL="0" indent="0">
               <a:buNone/>
             </a:pPr>
             <a:r>
@@ -6045,7 +6200,7 @@
           <a:bodyPr wrap="square" rtlCol="0" anchor="ctr"/>
           <a:lstStyle/>
           <a:p>
-            <a:pPr indent="0" marL="0">
+            <a:pPr marL="0" indent="0">
               <a:buNone/>
             </a:pPr>
             <a:r>
@@ -6084,7 +6239,7 @@
           <a:bodyPr wrap="square" rtlCol="0" anchor="ctr"/>
           <a:lstStyle/>
           <a:p>
-            <a:pPr indent="0" marL="0">
+            <a:pPr marL="0" indent="0">
               <a:buNone/>
             </a:pPr>
             <a:r>
@@ -6123,6 +6278,13 @@
           </a:solidFill>
           <a:ln/>
         </p:spPr>
+        <p:txBody>
+          <a:bodyPr/>
+          <a:lstStyle/>
+          <a:p>
+            <a:endParaRPr lang="de-DE"/>
+          </a:p>
+        </p:txBody>
       </p:sp>
       <p:sp>
         <p:nvSpPr>
@@ -6145,9 +6307,6 @@
           <a:bodyPr wrap="square" rtlCol="0" anchor="ctr"/>
           <a:lstStyle/>
           <a:p>
-            <a:pPr indent="0" marL="0">
-              <a:buNone/>
-            </a:pPr>
             <a:r>
               <a:rPr lang="en-US" sz="1050" dirty="0">
                 <a:solidFill>
@@ -6157,62 +6316,84 @@
                 <a:ea typeface="Calibri" pitchFamily="34" charset="-122"/>
                 <a:cs typeface="Calibri" pitchFamily="34" charset="-120"/>
               </a:rPr>
-              <a:t>Live URL: [to be added on deploy]</a:t>
-            </a:r>
-            <a:endParaRPr lang="en-US" sz="1050" dirty="0"/>
-          </a:p>
-          <a:p>
-            <a:pPr indent="0" marL="0">
-              <a:buNone/>
-            </a:pPr>
+              <a:t>Live URL: </a:t>
+            </a:r>
             <a:r>
               <a:rPr lang="en-US" sz="1050" dirty="0">
                 <a:solidFill>
-                  <a:srgbClr val="FFFFFF"/>
+                  <a:srgbClr val="DAEBF4"/>
                 </a:solidFill>
                 <a:latin typeface="Calibri" pitchFamily="34" charset="0"/>
                 <a:ea typeface="Calibri" pitchFamily="34" charset="-122"/>
                 <a:cs typeface="Calibri" pitchFamily="34" charset="-120"/>
-              </a:rPr>
-              <a:t>Repo: github.com/&lt;user&gt;/olist-brazil-project</a:t>
-            </a:r>
-            <a:endParaRPr lang="en-US" sz="1050" dirty="0"/>
-          </a:p>
-        </p:txBody>
-      </p:sp>
-      <p:sp>
-        <p:nvSpPr>
-          <p:cNvPr id="23" name="Text 17"/>
-          <p:cNvSpPr/>
-          <p:nvPr/>
-        </p:nvSpPr>
-        <p:spPr>
-          <a:xfrm>
-            <a:off x="457200" y="6537960"/>
-            <a:ext cx="7315200" cy="274320"/>
-          </a:xfrm>
-          <a:prstGeom prst="rect">
-            <a:avLst/>
-          </a:prstGeom>
-          <a:noFill/>
-          <a:ln/>
-        </p:spPr>
-        <p:txBody>
-          <a:bodyPr wrap="square" rtlCol="0" anchor="ctr"/>
-          <a:lstStyle/>
-          <a:p>
-            <a:pPr indent="0" marL="0">
-              <a:buNone/>
-            </a:pPr>
-            <a:r>
-              <a:rPr lang="en-US" sz="900" dirty="0">
-                <a:solidFill>
-                  <a:srgbClr val="8A93A6"/>
+                <a:hlinkClick r:id="rId7">
+                  <a:extLst>
+                    <a:ext uri="{A12FA001-AC4F-418D-AE19-62706E023703}">
+                      <ahyp:hlinkClr xmlns:ahyp="http://schemas.microsoft.com/office/drawing/2018/hyperlinkcolor" val="tx"/>
+                    </a:ext>
+                  </a:extLst>
+                </a:hlinkClick>
+              </a:rPr>
+              <a:t>https://brazilian-e-commerce-analysis-guilherme.streamlit.app/</a:t>
+            </a:r>
+            <a:endParaRPr lang="en-US" sz="1050" dirty="0">
+              <a:solidFill>
+                <a:srgbClr val="DAEBF4"/>
+              </a:solidFill>
+              <a:latin typeface="Calibri" pitchFamily="34" charset="0"/>
+              <a:ea typeface="Calibri" pitchFamily="34" charset="-122"/>
+              <a:cs typeface="Calibri" pitchFamily="34" charset="-120"/>
+            </a:endParaRPr>
+          </a:p>
+          <a:p>
+            <a:r>
+              <a:rPr lang="en-US" sz="1050" dirty="0">
+                <a:solidFill>
+                  <a:srgbClr val="FFFFFF"/>
                 </a:solidFill>
                 <a:latin typeface="Calibri" pitchFamily="34" charset="0"/>
                 <a:ea typeface="Calibri" pitchFamily="34" charset="-122"/>
                 <a:cs typeface="Calibri" pitchFamily="34" charset="-120"/>
               </a:rPr>
+              <a:t>Repo: https://github.com/GuiAvella/Brazilian-E-Commerce-Analysis</a:t>
+            </a:r>
+            <a:endParaRPr lang="en-US" sz="1050" dirty="0"/>
+          </a:p>
+        </p:txBody>
+      </p:sp>
+      <p:sp>
+        <p:nvSpPr>
+          <p:cNvPr id="23" name="Text 17"/>
+          <p:cNvSpPr/>
+          <p:nvPr/>
+        </p:nvSpPr>
+        <p:spPr>
+          <a:xfrm>
+            <a:off x="457200" y="6537960"/>
+            <a:ext cx="7315200" cy="274320"/>
+          </a:xfrm>
+          <a:prstGeom prst="rect">
+            <a:avLst/>
+          </a:prstGeom>
+          <a:noFill/>
+          <a:ln/>
+        </p:spPr>
+        <p:txBody>
+          <a:bodyPr wrap="square" rtlCol="0" anchor="ctr"/>
+          <a:lstStyle/>
+          <a:p>
+            <a:pPr marL="0" indent="0">
+              <a:buNone/>
+            </a:pPr>
+            <a:r>
+              <a:rPr lang="en-US" sz="900" dirty="0">
+                <a:solidFill>
+                  <a:srgbClr val="8A93A6"/>
+                </a:solidFill>
+                <a:latin typeface="Calibri" pitchFamily="34" charset="0"/>
+                <a:ea typeface="Calibri" pitchFamily="34" charset="-122"/>
+                <a:cs typeface="Calibri" pitchFamily="34" charset="-120"/>
+              </a:rPr>
               <a:t>Brazil's Marketplace in Motion  ·  Data Visualization Final Project</a:t>
             </a:r>
             <a:endParaRPr lang="en-US" sz="900" dirty="0"/>
@@ -6240,7 +6421,7 @@
           <a:bodyPr wrap="square" rtlCol="0" anchor="ctr"/>
           <a:lstStyle/>
           <a:p>
-            <a:pPr algn="r" indent="0" marL="0">
+            <a:pPr marL="0" indent="0" algn="r">
               <a:buNone/>
             </a:pPr>
             <a:r>
@@ -6559,4 +6740,319 @@
     </a:ext>
   </a:extLst>
 </a:theme>
+</file>
+
+<file path=ppt/theme/theme2.xml><?xml version="1.0" encoding="utf-8"?>
+<a:theme xmlns:a="http://schemas.openxmlformats.org/drawingml/2006/main" name="Office Theme">
+  <a:themeElements>
+    <a:clrScheme name="Office">
+      <a:dk1>
+        <a:sysClr val="windowText" lastClr="000000"/>
+      </a:dk1>
+      <a:lt1>
+        <a:sysClr val="window" lastClr="FFFFFF"/>
+      </a:lt1>
+      <a:dk2>
+        <a:srgbClr val="0E2841"/>
+      </a:dk2>
+      <a:lt2>
+        <a:srgbClr val="E8E8E8"/>
+      </a:lt2>
+      <a:accent1>
+        <a:srgbClr val="156082"/>
+      </a:accent1>
+      <a:accent2>
+        <a:srgbClr val="E97132"/>
+      </a:accent2>
+      <a:accent3>
+        <a:srgbClr val="196B24"/>
+      </a:accent3>
+      <a:accent4>
+        <a:srgbClr val="0F9ED5"/>
+      </a:accent4>
+      <a:accent5>
+        <a:srgbClr val="A02B93"/>
+      </a:accent5>
+      <a:accent6>
+        <a:srgbClr val="4EA72E"/>
+      </a:accent6>
+      <a:hlink>
+        <a:srgbClr val="467886"/>
+      </a:hlink>
+      <a:folHlink>
+        <a:srgbClr val="96607D"/>
+      </a:folHlink>
+    </a:clrScheme>
+    <a:fontScheme name="Office">
+      <a:majorFont>
+        <a:latin typeface="Aptos Display" panose="02110004020202020204"/>
+        <a:ea typeface=""/>
+        <a:cs typeface=""/>
+        <a:font script="Jpan" typeface="游ゴシック Light"/>
+        <a:font script="Hang" typeface="맑은 고딕"/>
+        <a:font script="Hans" typeface="等线 Light"/>
+        <a:font script="Hant" typeface="新細明體"/>
+        <a:font script="Arab" typeface="Times New Roman"/>
+        <a:font script="Hebr" typeface="Times New Roman"/>
+        <a:font script="Thai" typeface="Angsana New"/>
+        <a:font script="Ethi" typeface="Nyala"/>
+        <a:font script="Beng" typeface="Vrinda"/>
+        <a:font script="Gujr" typeface="Shruti"/>
+        <a:font script="Khmr" typeface="MoolBoran"/>
+        <a:font script="Knda" typeface="Tunga"/>
+        <a:font script="Guru" typeface="Raavi"/>
+        <a:font script="Cans" typeface="Euphemia"/>
+        <a:font script="Cher" typeface="Plantagenet Cherokee"/>
+        <a:font script="Yiii" typeface="Microsoft Yi Baiti"/>
+        <a:font script="Tibt" typeface="Microsoft Himalaya"/>
+        <a:font script="Thaa" typeface="MV Boli"/>
+        <a:font script="Deva" typeface="Mangal"/>
+        <a:font script="Telu" typeface="Gautami"/>
+        <a:font script="Taml" typeface="Latha"/>
+        <a:font script="Syrc" typeface="Estrangelo Edessa"/>
+        <a:font script="Orya" typeface="Kalinga"/>
+        <a:font script="Mlym" typeface="Kartika"/>
+        <a:font script="Laoo" typeface="DokChampa"/>
+        <a:font script="Sinh" typeface="Iskoola Pota"/>
+        <a:font script="Mong" typeface="Mongolian Baiti"/>
+        <a:font script="Viet" typeface="Times New Roman"/>
+        <a:font script="Uigh" typeface="Microsoft Uighur"/>
+        <a:font script="Geor" typeface="Sylfaen"/>
+        <a:font script="Armn" typeface="Arial"/>
+        <a:font script="Bugi" typeface="Leelawadee UI"/>
+        <a:font script="Bopo" typeface="Microsoft JhengHei"/>
+        <a:font script="Java" typeface="Javanese Text"/>
+        <a:font script="Lisu" typeface="Segoe UI"/>
+        <a:font script="Mymr" typeface="Myanmar Text"/>
+        <a:font script="Nkoo" typeface="Ebrima"/>
+        <a:font script="Olck" typeface="Nirmala UI"/>
+        <a:font script="Osma" typeface="Ebrima"/>
+        <a:font script="Phag" typeface="Phagspa"/>
+        <a:font script="Syrn" typeface="Estrangelo Edessa"/>
+        <a:font script="Syrj" typeface="Estrangelo Edessa"/>
+        <a:font script="Syre" typeface="Estrangelo Edessa"/>
+        <a:font script="Sora" typeface="Nirmala UI"/>
+        <a:font script="Tale" typeface="Microsoft Tai Le"/>
+        <a:font script="Talu" typeface="Microsoft New Tai Lue"/>
+        <a:font script="Tfng" typeface="Ebrima"/>
+      </a:majorFont>
+      <a:minorFont>
+        <a:latin typeface="Aptos" panose="02110004020202020204"/>
+        <a:ea typeface=""/>
+        <a:cs typeface=""/>
+        <a:font script="Jpan" typeface="游ゴシック"/>
+        <a:font script="Hang" typeface="맑은 고딕"/>
+        <a:font script="Hans" typeface="等线"/>
+        <a:font script="Hant" typeface="新細明體"/>
+        <a:font script="Arab" typeface="Arial"/>
+        <a:font script="Hebr" typeface="Arial"/>
+        <a:font script="Thai" typeface="Cordia New"/>
+        <a:font script="Ethi" typeface="Nyala"/>
+        <a:font script="Beng" typeface="Vrinda"/>
+        <a:font script="Gujr" typeface="Shruti"/>
+        <a:font script="Khmr" typeface="DaunPenh"/>
+        <a:font script="Knda" typeface="Tunga"/>
+        <a:font script="Guru" typeface="Raavi"/>
+        <a:font script="Cans" typeface="Euphemia"/>
+        <a:font script="Cher" typeface="Plantagenet Cherokee"/>
+        <a:font script="Yiii" typeface="Microsoft Yi Baiti"/>
+        <a:font script="Tibt" typeface="Microsoft Himalaya"/>
+        <a:font script="Thaa" typeface="MV Boli"/>
+        <a:font script="Deva" typeface="Mangal"/>
+        <a:font script="Telu" typeface="Gautami"/>
+        <a:font script="Taml" typeface="Latha"/>
+        <a:font script="Syrc" typeface="Estrangelo Edessa"/>
+        <a:font script="Orya" typeface="Kalinga"/>
+        <a:font script="Mlym" typeface="Kartika"/>
+        <a:font script="Laoo" typeface="DokChampa"/>
+        <a:font script="Sinh" typeface="Iskoola Pota"/>
+        <a:font script="Mong" typeface="Mongolian Baiti"/>
+        <a:font script="Viet" typeface="Arial"/>
+        <a:font script="Uigh" typeface="Microsoft Uighur"/>
+        <a:font script="Geor" typeface="Sylfaen"/>
+        <a:font script="Armn" typeface="Arial"/>
+        <a:font script="Bugi" typeface="Leelawadee UI"/>
+        <a:font script="Bopo" typeface="Microsoft JhengHei"/>
+        <a:font script="Java" typeface="Javanese Text"/>
+        <a:font script="Lisu" typeface="Segoe UI"/>
+        <a:font script="Mymr" typeface="Myanmar Text"/>
+        <a:font script="Nkoo" typeface="Ebrima"/>
+        <a:font script="Olck" typeface="Nirmala UI"/>
+        <a:font script="Osma" typeface="Ebrima"/>
+        <a:font script="Phag" typeface="Phagspa"/>
+        <a:font script="Syrn" typeface="Estrangelo Edessa"/>
+        <a:font script="Syrj" typeface="Estrangelo Edessa"/>
+        <a:font script="Syre" typeface="Estrangelo Edessa"/>
+        <a:font script="Sora" typeface="Nirmala UI"/>
+        <a:font script="Tale" typeface="Microsoft Tai Le"/>
+        <a:font script="Talu" typeface="Microsoft New Tai Lue"/>
+        <a:font script="Tfng" typeface="Ebrima"/>
+      </a:minorFont>
+    </a:fontScheme>
+    <a:fmtScheme name="Office">
+      <a:fillStyleLst>
+        <a:solidFill>
+          <a:schemeClr val="phClr"/>
+        </a:solidFill>
+        <a:gradFill rotWithShape="1">
+          <a:gsLst>
+            <a:gs pos="0">
+              <a:schemeClr val="phClr">
+                <a:lumMod val="110000"/>
+                <a:satMod val="105000"/>
+                <a:tint val="67000"/>
+              </a:schemeClr>
+            </a:gs>
+            <a:gs pos="50000">
+              <a:schemeClr val="phClr">
+                <a:lumMod val="105000"/>
+                <a:satMod val="103000"/>
+                <a:tint val="73000"/>
+              </a:schemeClr>
+            </a:gs>
+            <a:gs pos="100000">
+              <a:schemeClr val="phClr">
+                <a:lumMod val="105000"/>
+                <a:satMod val="109000"/>
+                <a:tint val="81000"/>
+              </a:schemeClr>
+            </a:gs>
+          </a:gsLst>
+          <a:lin ang="5400000" scaled="0"/>
+        </a:gradFill>
+        <a:gradFill rotWithShape="1">
+          <a:gsLst>
+            <a:gs pos="0">
+              <a:schemeClr val="phClr">
+                <a:satMod val="103000"/>
+                <a:lumMod val="102000"/>
+                <a:tint val="94000"/>
+              </a:schemeClr>
+            </a:gs>
+            <a:gs pos="50000">
+              <a:schemeClr val="phClr">
+                <a:satMod val="110000"/>
+                <a:lumMod val="100000"/>
+                <a:shade val="100000"/>
+              </a:schemeClr>
+            </a:gs>
+            <a:gs pos="100000">
+              <a:schemeClr val="phClr">
+                <a:lumMod val="99000"/>
+                <a:satMod val="120000"/>
+                <a:shade val="78000"/>
+              </a:schemeClr>
+            </a:gs>
+          </a:gsLst>
+          <a:lin ang="5400000" scaled="0"/>
+        </a:gradFill>
+      </a:fillStyleLst>
+      <a:lnStyleLst>
+        <a:ln w="12700" cap="flat" cmpd="sng" algn="ctr">
+          <a:solidFill>
+            <a:schemeClr val="phClr"/>
+          </a:solidFill>
+          <a:prstDash val="solid"/>
+          <a:miter lim="800000"/>
+        </a:ln>
+        <a:ln w="19050" cap="flat" cmpd="sng" algn="ctr">
+          <a:solidFill>
+            <a:schemeClr val="phClr"/>
+          </a:solidFill>
+          <a:prstDash val="solid"/>
+          <a:miter lim="800000"/>
+        </a:ln>
+        <a:ln w="25400" cap="flat" cmpd="sng" algn="ctr">
+          <a:solidFill>
+            <a:schemeClr val="phClr"/>
+          </a:solidFill>
+          <a:prstDash val="solid"/>
+          <a:miter lim="800000"/>
+        </a:ln>
+      </a:lnStyleLst>
+      <a:effectStyleLst>
+        <a:effectStyle>
+          <a:effectLst/>
+        </a:effectStyle>
+        <a:effectStyle>
+          <a:effectLst/>
+        </a:effectStyle>
+        <a:effectStyle>
+          <a:effectLst>
+            <a:outerShdw blurRad="57150" dist="19050" dir="5400000" algn="ctr" rotWithShape="0">
+              <a:srgbClr val="000000">
+                <a:alpha val="63000"/>
+              </a:srgbClr>
+            </a:outerShdw>
+          </a:effectLst>
+        </a:effectStyle>
+      </a:effectStyleLst>
+      <a:bgFillStyleLst>
+        <a:solidFill>
+          <a:schemeClr val="phClr"/>
+        </a:solidFill>
+        <a:solidFill>
+          <a:schemeClr val="phClr">
+            <a:tint val="95000"/>
+            <a:satMod val="170000"/>
+          </a:schemeClr>
+        </a:solidFill>
+        <a:gradFill rotWithShape="1">
+          <a:gsLst>
+            <a:gs pos="0">
+              <a:schemeClr val="phClr">
+                <a:tint val="93000"/>
+                <a:satMod val="150000"/>
+                <a:shade val="98000"/>
+                <a:lumMod val="102000"/>
+              </a:schemeClr>
+            </a:gs>
+            <a:gs pos="50000">
+              <a:schemeClr val="phClr">
+                <a:tint val="98000"/>
+                <a:satMod val="130000"/>
+                <a:shade val="90000"/>
+                <a:lumMod val="103000"/>
+              </a:schemeClr>
+            </a:gs>
+            <a:gs pos="100000">
+              <a:schemeClr val="phClr">
+                <a:shade val="63000"/>
+                <a:satMod val="120000"/>
+              </a:schemeClr>
+            </a:gs>
+          </a:gsLst>
+          <a:lin ang="5400000" scaled="0"/>
+        </a:gradFill>
+      </a:bgFillStyleLst>
+    </a:fmtScheme>
+  </a:themeElements>
+  <a:objectDefaults>
+    <a:lnDef>
+      <a:spPr/>
+      <a:bodyPr/>
+      <a:lstStyle/>
+      <a:style>
+        <a:lnRef idx="2">
+          <a:schemeClr val="accent1"/>
+        </a:lnRef>
+        <a:fillRef idx="0">
+          <a:schemeClr val="accent1"/>
+        </a:fillRef>
+        <a:effectRef idx="1">
+          <a:schemeClr val="accent1"/>
+        </a:effectRef>
+        <a:fontRef idx="minor">
+          <a:schemeClr val="tx1"/>
+        </a:fontRef>
+      </a:style>
+    </a:lnDef>
+  </a:objectDefaults>
+  <a:extraClrSchemeLst/>
+  <a:extLst>
+    <a:ext uri="{05A4C25C-085E-4340-85A3-A5531E510DB2}">
+      <thm15:themeFamily xmlns:thm15="http://schemas.microsoft.com/office/thememl/2012/main" name="Office Theme" id="{2E142A2C-CD16-42D6-873A-C26D2A0506FA}" vid="{1BDDFF52-6CD6-40A5-AB3C-68EB2F1E4D0A}"/>
+    </a:ext>
+  </a:extLst>
+</a:theme>
 </file>
</xml_diff>